<commit_message>
docs: perbarui DESIGN.md, status, serah terima, indeks, dan PPT sesuai aplikasi terkini
- DESIGN.md ditulis ulang: arah Apple Store, token --tile, sistem tombol, gerak CSS, layout admin
- PPT: slide 1,5,6,7,10-13,16,19,20 (26 teks) dan 4 gambar mockup diganti tangkapan layar aplikasi; validator PPTX lulus
- PROJECT_STATUS/PROGRESS/SERAH_TERIMA/README/indeks/CLAUDE.md disesuaikan (Vercel Blob, SMTP, Midtrans sandbox, hasil uji)
</commit_message>
<xml_diff>
--- a/docs/Presentasi_ECommerce_TokoKita.pptx
+++ b/docs/Presentasi_ECommerce_TokoKita.pptx
@@ -2444,7 +2444,7 @@
                 <a:ea typeface="Calibri" pitchFamily="34" charset="-122"/>
                 <a:cs typeface="Calibri" pitchFamily="34" charset="-120"/>
               </a:rPr>
-              <a:t>Rencana Pembangunan Toko Online Mandiri</a:t>
+              <a:t>Toko Online Mandiri: Hasil Pembangunan</a:t>
             </a:r>
             <a:endParaRPr lang="en-US" sz="2600" dirty="0"/>
           </a:p>
@@ -2483,7 +2483,7 @@
                 <a:ea typeface="Calibri" pitchFamily="34" charset="-122"/>
                 <a:cs typeface="Calibri" pitchFamily="34" charset="-120"/>
               </a:rPr>
-              <a:t>Ruang lingkup, arsitektur, desain antarmuka, pembagian tim, dan target MVP berdasarkan PRD.</a:t>
+              <a:t>Ruang lingkup, arsitektur, desain antarmuka, hasil pengujian, dan status rilis berdasarkan PRD.</a:t>
             </a:r>
             <a:endParaRPr lang="en-US" sz="1500" dirty="0"/>
           </a:p>
@@ -2702,7 +2702,7 @@
                 <a:ea typeface="Calibri" pitchFamily="34" charset="-122"/>
                 <a:cs typeface="Calibri" pitchFamily="34" charset="-120"/>
               </a:rPr>
-              <a:t>Mockup beranda TokoKita</a:t>
+              <a:t>Tampilan beranda TokoKita</a:t>
             </a:r>
             <a:endParaRPr lang="en-US" sz="1100" dirty="0"/>
           </a:p>
@@ -3239,7 +3239,7 @@
                 <a:ea typeface="Calibri" pitchFamily="34" charset="-122"/>
                 <a:cs typeface="Calibri" pitchFamily="34" charset="-120"/>
               </a:rPr>
-              <a:t>Carousel promosi yang dikelola admin.</a:t>
+              <a:t>Carousel geser, dikelola admin.</a:t>
             </a:r>
             <a:endParaRPr lang="en-US" sz="1300" dirty="0"/>
           </a:p>
@@ -3358,7 +3358,7 @@
                 <a:ea typeface="Calibri" pitchFamily="34" charset="-122"/>
                 <a:cs typeface="Calibri" pitchFamily="34" charset="-120"/>
               </a:rPr>
-              <a:t>Ikon kategori besar dan mudah disentuh.</a:t>
+              <a:t>Ubin kategori besar dan mudah disentuh.</a:t>
             </a:r>
             <a:endParaRPr lang="en-US" sz="1300" dirty="0"/>
           </a:p>
@@ -10504,7 +10504,7 @@
                 <a:ea typeface="Calibri" pitchFamily="34" charset="-122"/>
                 <a:cs typeface="Calibri" pitchFamily="34" charset="-120"/>
               </a:rPr>
-              <a:t>Skor performa ≥ 90 di halaman utama</a:t>
+              <a:t>Hasil: desktop 100, seluler 91–92 (LCP ~3 dtk)</a:t>
             </a:r>
             <a:endParaRPr lang="en-US" sz="1200" dirty="0"/>
           </a:p>
@@ -10626,7 +10626,7 @@
                 <a:ea typeface="Calibri" pitchFamily="34" charset="-122"/>
                 <a:cs typeface="Calibri" pitchFamily="34" charset="-120"/>
               </a:rPr>
-              <a:t>Android dan iPhone, layar mulai 360 px</a:t>
+              <a:t>Chrome, Edge, Firefox, Safari; layar 360 px</a:t>
             </a:r>
             <a:endParaRPr lang="en-US" sz="1200" dirty="0"/>
           </a:p>
@@ -10748,7 +10748,7 @@
                 <a:ea typeface="Calibri" pitchFamily="34" charset="-122"/>
                 <a:cs typeface="Calibri" pitchFamily="34" charset="-120"/>
               </a:rPr>
-              <a:t>Dari cari produk sampai pesanan selesai</a:t>
+              <a:t>Cari produk sampai pesanan selesai: lulus</a:t>
             </a:r>
             <a:endParaRPr lang="en-US" sz="1200" dirty="0"/>
           </a:p>
@@ -10870,7 +10870,7 @@
                 <a:ea typeface="Calibri" pitchFamily="34" charset="-122"/>
                 <a:cs typeface="Calibri" pitchFamily="34" charset="-120"/>
               </a:rPr>
-              <a:t>Memastikan stok tidak terjual berlebih</a:t>
+              <a:t>Teruji: dua pembeli, satu stok terakhir</a:t>
             </a:r>
             <a:endParaRPr lang="en-US" sz="1200" dirty="0"/>
           </a:p>
@@ -14758,7 +14758,7 @@
                 <a:ea typeface="Calibri" pitchFamily="34" charset="-122"/>
                 <a:cs typeface="Calibri" pitchFamily="34" charset="-120"/>
               </a:rPr>
-              <a:t>Checkout dengan kode promo HEMAT10</a:t>
+              <a:t>Checkout kode HEMAT10 (min. Rp 100.000)</a:t>
             </a:r>
             <a:endParaRPr lang="en-US" sz="1400" dirty="0"/>
           </a:p>
@@ -15088,7 +15088,7 @@
                 <a:ea typeface="Calibri" pitchFamily="34" charset="-122"/>
                 <a:cs typeface="Calibri" pitchFamily="34" charset="-120"/>
               </a:rPr>
-              <a:t>Belum memakai payment gateway: Midtrans/Xendit mensyaratkan badan usaha (PT/CV). Tahap ini memakai transfer bank, QRIS, dan COD dengan konfirmasi admin.</a:t>
+              <a:t>Pembayaran: Midtrans sandbox (BCA, Mandiri; QRIS tertunda). Uang asli butuh badan usaha (PT/CV), jadi COD dan konfirmasi admin tetap tersedia.</a:t>
             </a:r>
             <a:endParaRPr lang="en-US" sz="1100" dirty="0"/>
           </a:p>
@@ -15331,7 +15331,7 @@
                 <a:ea typeface="Calibri" pitchFamily="34" charset="-122"/>
                 <a:cs typeface="Calibri" pitchFamily="34" charset="-120"/>
               </a:rPr>
-              <a:t>20–30 produk dengan varian &amp; berat</a:t>
+              <a:t>26 produk dengan varian &amp; berat</a:t>
             </a:r>
             <a:endParaRPr lang="en-US" sz="1300" dirty="0"/>
           </a:p>
@@ -15394,7 +15394,7 @@
                 <a:ea typeface="Calibri" pitchFamily="34" charset="-122"/>
                 <a:cs typeface="Calibri" pitchFamily="34" charset="-120"/>
               </a:rPr>
-              <a:t>10–15 pesanan di semua status</a:t>
+              <a:t>79 pesanan di semua status</a:t>
             </a:r>
             <a:endParaRPr lang="en-US" sz="1300" dirty="0"/>
           </a:p>
@@ -15574,7 +15574,7 @@
                 <a:ea typeface="Calibri" pitchFamily="34" charset="-122"/>
                 <a:cs typeface="Calibri" pitchFamily="34" charset="-120"/>
               </a:rPr>
-              <a:t>VPS Indonesia (Nginx + PM2)</a:t>
+              <a:t>Vercel (aplikasi) + Aiven (MySQL)</a:t>
             </a:r>
             <a:endParaRPr lang="en-US" sz="1300" dirty="0"/>
           </a:p>
@@ -15637,7 +15637,7 @@
                 <a:ea typeface="Calibri" pitchFamily="34" charset="-122"/>
                 <a:cs typeface="Calibri" pitchFamily="34" charset="-120"/>
               </a:rPr>
-              <a:t>HTTPS gratis dari Let's Encrypt</a:t>
+              <a:t>HTTPS otomatis dari Vercel</a:t>
             </a:r>
             <a:endParaRPr lang="en-US" sz="1300" dirty="0"/>
           </a:p>
@@ -15700,7 +15700,7 @@
                 <a:ea typeface="Calibri" pitchFamily="34" charset="-122"/>
                 <a:cs typeface="Calibri" pitchFamily="34" charset="-120"/>
               </a:rPr>
-              <a:t>Backup MySQL harian &amp; mingguan</a:t>
+              <a:t>Cadangan manual (jadwal otomatis belum)</a:t>
             </a:r>
             <a:endParaRPr lang="en-US" sz="1300" dirty="0"/>
           </a:p>
@@ -16945,7 +16945,7 @@
                 <a:ea typeface="Calibri" pitchFamily="34" charset="-122"/>
                 <a:cs typeface="Calibri" pitchFamily="34" charset="-120"/>
               </a:rPr>
-              <a:t>Tim kami siap menuntaskan TokoKita bersama.</a:t>
+              <a:t>TokoKita sudah berjalan online dan siap didemokan.</a:t>
             </a:r>
             <a:endParaRPr lang="en-US" sz="2000" dirty="0"/>
           </a:p>
@@ -17094,7 +17094,7 @@
                 <a:ea typeface="Calibri" pitchFamily="34" charset="-122"/>
                 <a:cs typeface="Calibri" pitchFamily="34" charset="-120"/>
               </a:rPr>
-              <a:t>Mockup beranda, detail produk, checkout, dan admin sudah ada.</a:t>
+              <a:t>Beranda, detail produk, checkout, dan admin sudah berjalan.</a:t>
             </a:r>
             <a:endParaRPr lang="en-US" sz="1300" dirty="0"/>
           </a:p>
@@ -17541,7 +17541,7 @@
                 <a:ea typeface="Calibri" pitchFamily="34" charset="-122"/>
                 <a:cs typeface="Calibri" pitchFamily="34" charset="-120"/>
               </a:rPr>
-              <a:t>Alur inti transaksi solid dan siap didemokan.</a:t>
+              <a:t>Alur belanja sampai bayar sandbox sudah teruji.</a:t>
             </a:r>
             <a:endParaRPr lang="en-US" sz="1300" dirty="0"/>
           </a:p>
@@ -20885,7 +20885,7 @@
                 <a:ea typeface="Calibri" pitchFamily="34" charset="-122"/>
                 <a:cs typeface="Calibri" pitchFamily="34" charset="-120"/>
               </a:rPr>
-              <a:t>Lanjutan</a:t>
+              <a:t>Lanjutan  ·  Selesai</a:t>
             </a:r>
             <a:endParaRPr lang="en-US" sz="1400" dirty="0"/>
           </a:p>
@@ -21277,7 +21277,7 @@
                 <a:ea typeface="Calibri" pitchFamily="34" charset="-122"/>
                 <a:cs typeface="Calibri" pitchFamily="34" charset="-120"/>
               </a:rPr>
-              <a:t>Payment gateway otomatis</a:t>
+              <a:t>Pembayaran uang asli</a:t>
             </a:r>
             <a:endParaRPr lang="en-US" sz="1300" dirty="0"/>
           </a:p>
@@ -22108,7 +22108,7 @@
                 <a:ea typeface="Calibri" pitchFamily="34" charset="-122"/>
                 <a:cs typeface="Calibri" pitchFamily="34" charset="-120"/>
               </a:rPr>
-              <a:t>Stabil, gratis, sudah dipelajari di kampus, dan berjalan lokal lewat XAMPP.</a:t>
+              <a:t>Stabil, sudah dipelajari di kampus; berjalan di Aiven (cloud) dan lokal lewat Laragon.</a:t>
             </a:r>
             <a:endParaRPr lang="en-US" sz="1300" dirty="0"/>
           </a:p>
@@ -23721,7 +23721,7 @@
                 <a:ea typeface="Calibri" pitchFamily="34" charset="-122"/>
                 <a:cs typeface="Calibri" pitchFamily="34" charset="-120"/>
               </a:rPr>
-              <a:t>/api/search (saran cari)  ·  /api/cron (job terjadwal)</a:t>
+              <a:t>/api/search  ·  /api/cron  ·  /api/payment/midtrans</a:t>
             </a:r>
             <a:endParaRPr lang="en-US" sz="1200" dirty="0"/>
           </a:p>
@@ -24081,7 +24081,7 @@
                 <a:ea typeface="Calibri" pitchFamily="34" charset="-122"/>
                 <a:cs typeface="Calibri" pitchFamily="34" charset="-120"/>
               </a:rPr>
-              <a:t>15 tabel</a:t>
+              <a:t>15 tabel · Aiven</a:t>
             </a:r>
             <a:endParaRPr lang="en-US" sz="1100" dirty="0"/>
           </a:p>
@@ -24378,7 +24378,7 @@
                 <a:ea typeface="Calibri" pitchFamily="34" charset="-122"/>
                 <a:cs typeface="Calibri" pitchFamily="34" charset="-120"/>
               </a:rPr>
-              <a:t>Lokal saat dev, Cloudflare R2 saat rilis</a:t>
+              <a:t>Lokal saat dev, Vercel Blob saat rilis</a:t>
             </a:r>
             <a:endParaRPr lang="en-US" sz="1100" dirty="0"/>
           </a:p>
@@ -24507,7 +24507,7 @@
                 <a:ea typeface="Calibri" pitchFamily="34" charset="-122"/>
                 <a:cs typeface="Calibri" pitchFamily="34" charset="-120"/>
               </a:rPr>
-              <a:t>Tiap 15 menit: batal otomatis &amp; selesai otomatis</a:t>
+              <a:t>Harian di Vercel Hobby (15 menit di Pro)</a:t>
             </a:r>
             <a:endParaRPr lang="en-US" sz="1100" dirty="0"/>
           </a:p>

</xml_diff>

<commit_message>
docs: Argon2id, modal admin, Pilihan, konfirmasi keluar; PPT slide 10-13 dan 17
</commit_message>
<xml_diff>
--- a/docs/Presentasi_ECommerce_TokoKita.pptx
+++ b/docs/Presentasi_ECommerce_TokoKita.pptx
@@ -3200,7 +3200,7 @@
                 <a:ea typeface="Calibri" pitchFamily="34" charset="-122"/>
                 <a:cs typeface="Calibri" pitchFamily="34" charset="-120"/>
               </a:rPr>
-              <a:t>Banner promo</a:t>
+              <a:t>Hero foto penuh</a:t>
             </a:r>
             <a:endParaRPr lang="en-US" sz="1600" dirty="0"/>
           </a:p>
@@ -3239,7 +3239,7 @@
                 <a:ea typeface="Calibri" pitchFamily="34" charset="-122"/>
                 <a:cs typeface="Calibri" pitchFamily="34" charset="-120"/>
               </a:rPr>
-              <a:t>Carousel geser, dikelola admin.</a:t>
+              <a:t>Promo geser dari admin; ada mode gelap.</a:t>
             </a:r>
             <a:endParaRPr lang="en-US" sz="1300" dirty="0"/>
           </a:p>
@@ -5302,7 +5302,7 @@
                 <a:ea typeface="Calibri" pitchFamily="34" charset="-122"/>
                 <a:cs typeface="Calibri" pitchFamily="34" charset="-120"/>
               </a:rPr>
-              <a:t>Menu samping</a:t>
+              <a:t>Satu gaya dengan toko</a:t>
             </a:r>
             <a:endParaRPr lang="en-US" sz="1600" dirty="0"/>
           </a:p>
@@ -5341,7 +5341,7 @@
                 <a:ea typeface="Calibri" pitchFamily="34" charset="-122"/>
                 <a:cs typeface="Calibri" pitchFamily="34" charset="-120"/>
               </a:rPr>
-              <a:t>Pesanan, Produk, Kategori, Promo, dan Banner.</a:t>
+              <a:t>Menu pil, mode terang &amp; gelap.</a:t>
             </a:r>
             <a:endParaRPr lang="en-US" sz="1300" dirty="0"/>
           </a:p>
@@ -5659,7 +5659,7 @@
                 <a:ea typeface="Calibri" pitchFamily="34" charset="-122"/>
                 <a:cs typeface="Calibri" pitchFamily="34" charset="-120"/>
               </a:rPr>
-              <a:t>Proses pesanan</a:t>
+              <a:t>Tambah &amp; edit di modal</a:t>
             </a:r>
             <a:endParaRPr lang="en-US" sz="1600" dirty="0"/>
           </a:p>
@@ -5698,7 +5698,7 @@
                 <a:ea typeface="Calibri" pitchFamily="34" charset="-122"/>
                 <a:cs typeface="Calibri" pitchFamily="34" charset="-120"/>
               </a:rPr>
-              <a:t>Ubah status dan input resi dalam satu layar.</a:t>
+              <a:t>Form tampil di atas daftar, tanpa pindah halaman.</a:t>
             </a:r>
             <a:endParaRPr lang="en-US" sz="1300" dirty="0"/>
           </a:p>
@@ -11623,7 +11623,7 @@
                 <a:ea typeface="Calibri" pitchFamily="34" charset="-122"/>
                 <a:cs typeface="Calibri" pitchFamily="34" charset="-120"/>
               </a:rPr>
-              <a:t>Password dienkripsi bcrypt</a:t>
+              <a:t>Password di-hash Argon2id</a:t>
             </a:r>
             <a:endParaRPr lang="en-US" sz="1400" dirty="0"/>
           </a:p>

</xml_diff>

<commit_message>
docs: generator PPT di scripts/ppt, PPT diperbarui, aturan akhir sesi
</commit_message>
<xml_diff>
--- a/docs/Presentasi_ECommerce_TokoKita.pptx
+++ b/docs/Presentasi_ECommerce_TokoKita.pptx
@@ -128,20 +128,20 @@
   <p:extLst>
     <p:ext uri="{521415D9-36F7-43E2-AB2F-B90AF26B5E84}">
       <p14:sectionLst xmlns:p14="http://schemas.microsoft.com/office/powerpoint/2010/main">
-        <p14:section name="Pembuka" id="{c1e6a3e9-4812-3867-053d-7a06d7488b0c}">
+        <p14:section name="Pembuka" id="{fa386766-66da-469e-d389-5603a2491031}">
           <p14:sldIdLst>
             <p14:sldId id="256"/>
             <p14:sldId id="257"/>
           </p14:sldIdLst>
         </p14:section>
-        <p14:section name="Latar &amp; cakupan" id="{adf78a2c-bbf8-ef0d-99fe-665ab0ca5aa7}">
+        <p14:section name="Latar &amp; cakupan" id="{18e4b738-7b82-aff7-76b9-f296970f0df6}">
           <p14:sldIdLst>
             <p14:sldId id="258"/>
             <p14:sldId id="259"/>
             <p14:sldId id="260"/>
           </p14:sldIdLst>
         </p14:section>
-        <p14:section name="Teknologi" id="{d06eb133-a285-4e09-88a8-566969e1c7ec}">
+        <p14:section name="Teknologi" id="{98a0e16d-594d-64c1-6f20-c2f16d6e29e9}">
           <p14:sldIdLst>
             <p14:sldId id="261"/>
             <p14:sldId id="262"/>
@@ -149,7 +149,7 @@
             <p14:sldId id="264"/>
           </p14:sldIdLst>
         </p14:section>
-        <p14:section name="Tampilan aplikasi" id="{f369599e-8639-4936-c179-3f7de3664272}">
+        <p14:section name="Tampilan aplikasi" id="{c82735dc-affc-23eb-3e24-00bb38ebc43f}">
           <p14:sldIdLst>
             <p14:sldId id="265"/>
             <p14:sldId id="266"/>
@@ -159,13 +159,13 @@
             <p14:sldId id="270"/>
           </p14:sldIdLst>
         </p14:section>
-        <p14:section name="Tim &amp; cara kerja" id="{5f862a37-266c-5f48-d3b0-a65cbb4e23c5}">
+        <p14:section name="Tim &amp; cara kerja" id="{465eb0c1-af4e-ea75-43e8-56182a71af8d}">
           <p14:sldIdLst>
             <p14:sldId id="271"/>
             <p14:sldId id="272"/>
           </p14:sldIdLst>
         </p14:section>
-        <p14:section name="Kualitas &amp; demo" id="{ddbb4ae4-f0e0-f15a-93bc-35ef4f58bdcd}">
+        <p14:section name="Kualitas &amp; demo" id="{e8f9dd73-7e07-e2a9-e472-83c03caee086}">
           <p14:sldIdLst>
             <p14:sldId id="273"/>
             <p14:sldId id="274"/>
@@ -173,7 +173,7 @@
             <p14:sldId id="276"/>
           </p14:sldIdLst>
         </p14:section>
-        <p14:section name="Penutup" id="{0a4db206-0750-51fd-dd67-179632006f73}">
+        <p14:section name="Penutup" id="{9bf40b0c-fdf7-7617-8ddb-699a9e7138db}">
           <p14:sldIdLst>
             <p14:sldId id="277"/>
           </p14:sldIdLst>
@@ -1374,7 +1374,7 @@
           <a:p>
             <a:r>
               <a:rPr lang="en-US" dirty="0"/>
-              <a:t>Semua angka hasil pengujian nyata pada 3 Oktober 2026. Satu target belum tercapai di simulasi HP lambat: halaman katalog 3,4 detik; tanpa simulasi tampil 0,3 detik.</a:t>
+              <a:t>Semua angka hasil pengujian nyata pada 3 Oktober 2026. Kecepatan diukur dengan Lighthouse dan HP yang diperlambat (Slow 4G). Pada mode simulasi Lighthouse, halaman detail masih sekitar 3 detik; ini catatan perbaikan lanjutan.</a:t>
             </a:r>
             <a:endParaRPr lang="en-US" dirty="0"/>
           </a:p>
@@ -1726,7 +1726,7 @@
           <a:p>
             <a:r>
               <a:rPr lang="en-US" dirty="0"/>
-              <a:t>Demo memakai data awal agar toko tidak kosong. Pembayaran uang asli butuh akun Midtrans atas nama badan usaha, jadi demo memakai sandbox dan konfirmasi manual admin. Rekaman cadangan ada di docs/screenshots/demo-ppt.</a:t>
+              <a:t>Demo memakai data awal agar toko tidak kosong. Pembayaran uang asli butuh akun Midtrans atas nama badan usaha, jadi demo memakai sandbox dan konfirmasi manual admin. Rekaman cadangan ada di docs/screenshots/demo-ppt. Pembayaran sandbox sudah diuji di situs online sampai lunas otomatis; QRIS masih tertunda di simulator Midtrans.</a:t>
             </a:r>
             <a:endParaRPr lang="en-US" dirty="0"/>
           </a:p>
@@ -2254,7 +2254,7 @@
           <a:p>
             <a:r>
               <a:rPr lang="en-US" dirty="0"/>
-              <a:t>Alur: pengguna membuka halaman, Next.js memproses di server Vercel Singapura, Prisma menerjemahkan ke MySQL Aiven. Semua perubahan data hanya lewat Server Actions. Layanan pendukung: Blob untuk gambar, Gmail untuk email, Midtrans sandbox, cron harian, dan Gemini/Groq untuk asisten AI.</a:t>
+              <a:t>Alur: pengguna membuka halaman, Next.js memproses di server Vercel Singapura, Prisma menerjemahkan ke MySQL Aiven. Semua perubahan data hanya lewat Server Actions. Layanan pendukung: Blob untuk gambar, Gmail untuk email, Midtrans sandbox, cron pesanan tiap jam (GitHub Actions, cadangan cron harian Vercel) dengan backup database harian terenkripsi, dan Gemini/Groq untuk asisten AI. Email dikirim di latar agar checkout tidak menunggu.</a:t>
             </a:r>
             <a:endParaRPr lang="en-US" dirty="0"/>
           </a:p>
@@ -3346,7 +3346,7 @@
       </p:sp>
       <p:pic>
         <p:nvPicPr>
-          <p:cNvPr id="7" name="Image 0" descr="C:\Users\Ilham\AppData\Local\Temp\claude\C--laragon-www-e-commerce\f9bd3d3e-d07a-4d63-a45c-a6ddd58be178\scratchpad\deck\aset\beranda.png">    </p:cNvPr>
+          <p:cNvPr id="7" name="Image 0" descr="C:\laragon\www\e-commerce\scripts\ppt\aset\beranda.png">    </p:cNvPr>
           <p:cNvPicPr>
             <a:picLocks noChangeAspect="1"/>
           </p:cNvPicPr>
@@ -3370,7 +3370,7 @@
       </p:pic>
       <p:pic>
         <p:nvPicPr>
-          <p:cNvPr id="8" name="Image 1" descr="C:\Users\Ilham\AppData\Local\Temp\claude\C--laragon-www-e-commerce\f9bd3d3e-d07a-4d63-a45c-a6ddd58be178\scratchpad\deck\aset\hp-gelap.png">    </p:cNvPr>
+          <p:cNvPr id="8" name="Image 1" descr="C:\laragon\www\e-commerce\scripts\ppt\aset\hp-gelap.png">    </p:cNvPr>
           <p:cNvPicPr>
             <a:picLocks noChangeAspect="1"/>
           </p:cNvPicPr>
@@ -3599,7 +3599,7 @@
       </p:sp>
       <p:pic>
         <p:nvPicPr>
-          <p:cNvPr id="5" name="Image 0" descr="C:\Users\Ilham\AppData\Local\Temp\claude\C--laragon-www-e-commerce\f9bd3d3e-d07a-4d63-a45c-a6ddd58be178\scratchpad\deck\aset\beranda.png">    </p:cNvPr>
+          <p:cNvPr id="5" name="Image 0" descr="C:\laragon\www\e-commerce\scripts\ppt\aset\beranda.png">    </p:cNvPr>
           <p:cNvPicPr>
             <a:picLocks noChangeAspect="1"/>
           </p:cNvPicPr>
@@ -4346,7 +4346,7 @@
       </p:sp>
       <p:pic>
         <p:nvPicPr>
-          <p:cNvPr id="5" name="Image 0" descr="C:\Users\Ilham\AppData\Local\Temp\claude\C--laragon-www-e-commerce\f9bd3d3e-d07a-4d63-a45c-a6ddd58be178\scratchpad\deck\aset\katalog.png">    </p:cNvPr>
+          <p:cNvPr id="5" name="Image 0" descr="C:\laragon\www\e-commerce\scripts\ppt\aset\katalog.png">    </p:cNvPr>
           <p:cNvPicPr>
             <a:picLocks noChangeAspect="1"/>
           </p:cNvPicPr>
@@ -5093,7 +5093,7 @@
       </p:sp>
       <p:pic>
         <p:nvPicPr>
-          <p:cNvPr id="5" name="Image 0" descr="C:\Users\Ilham\AppData\Local\Temp\claude\C--laragon-www-e-commerce\f9bd3d3e-d07a-4d63-a45c-a6ddd58be178\scratchpad\deck\aset\detail.png">    </p:cNvPr>
+          <p:cNvPr id="5" name="Image 0" descr="C:\laragon\www\e-commerce\scripts\ppt\aset\detail.png">    </p:cNvPr>
           <p:cNvPicPr>
             <a:picLocks noChangeAspect="1"/>
           </p:cNvPicPr>
@@ -5840,7 +5840,7 @@
       </p:sp>
       <p:pic>
         <p:nvPicPr>
-          <p:cNvPr id="5" name="Image 0" descr="C:\Users\Ilham\AppData\Local\Temp\claude\C--laragon-www-e-commerce\f9bd3d3e-d07a-4d63-a45c-a6ddd58be178\scratchpad\deck\aset\checkout.png">    </p:cNvPr>
+          <p:cNvPr id="5" name="Image 0" descr="C:\laragon\www\e-commerce\scripts\ppt\aset\checkout.png">    </p:cNvPr>
           <p:cNvPicPr>
             <a:picLocks noChangeAspect="1"/>
           </p:cNvPicPr>
@@ -6587,7 +6587,7 @@
       </p:sp>
       <p:pic>
         <p:nvPicPr>
-          <p:cNvPr id="5" name="Image 0" descr="C:\Users\Ilham\AppData\Local\Temp\claude\C--laragon-www-e-commerce\f9bd3d3e-d07a-4d63-a45c-a6ddd58be178\scratchpad\deck\aset\admin-gelap.png">    </p:cNvPr>
+          <p:cNvPr id="5" name="Image 0" descr="C:\laragon\www\e-commerce\scripts\ppt\aset\admin-gelap.png">    </p:cNvPr>
           <p:cNvPicPr>
             <a:picLocks noChangeAspect="1"/>
           </p:cNvPicPr>
@@ -6611,7 +6611,7 @@
       </p:pic>
       <p:pic>
         <p:nvPicPr>
-          <p:cNvPr id="6" name="Image 1" descr="C:\Users\Ilham\AppData\Local\Temp\claude\C--laragon-www-e-commerce\f9bd3d3e-d07a-4d63-a45c-a6ddd58be178\scratchpad\deck\aset\admin-modal-potong.png">    </p:cNvPr>
+          <p:cNvPr id="6" name="Image 1" descr="C:\laragon\www\e-commerce\scripts\ppt\aset\admin-modal-potong.png">    </p:cNvPr>
           <p:cNvPicPr>
             <a:picLocks noChangeAspect="1"/>
           </p:cNvPicPr>
@@ -7358,7 +7358,7 @@
       </p:sp>
       <p:pic>
         <p:nvPicPr>
-          <p:cNvPr id="5" name="Image 0" descr="C:\Users\Ilham\AppData\Local\Temp\claude\C--laragon-www-e-commerce\f9bd3d3e-d07a-4d63-a45c-a6ddd58be178\scratchpad\deck\aset\hp-gelap.png">    </p:cNvPr>
+          <p:cNvPr id="5" name="Image 0" descr="C:\laragon\www\e-commerce\scripts\ppt\aset\hp-gelap.png">    </p:cNvPr>
           <p:cNvPicPr>
             <a:picLocks noChangeAspect="1"/>
           </p:cNvPicPr>
@@ -7382,7 +7382,7 @@
       </p:pic>
       <p:pic>
         <p:nvPicPr>
-          <p:cNvPr id="6" name="Image 1" descr="C:\Users\Ilham\AppData\Local\Temp\claude\C--laragon-www-e-commerce\f9bd3d3e-d07a-4d63-a45c-a6ddd58be178\scratchpad\deck\aset\asisten-panel.png">    </p:cNvPr>
+          <p:cNvPr id="6" name="Image 1" descr="C:\laragon\www\e-commerce\scripts\ppt\aset\asisten-panel.png">    </p:cNvPr>
           <p:cNvPicPr>
             <a:picLocks noChangeAspect="1"/>
           </p:cNvPicPr>
@@ -10245,7 +10245,7 @@
       </p:sp>
       <p:pic>
         <p:nvPicPr>
-          <p:cNvPr id="44" name="Image 0" descr="C:\Users\Ilham\AppData\Local\Temp\claude\C--laragon-www-e-commerce\f9bd3d3e-d07a-4d63-a45c-a6ddd58be178\scratchpad\deck\aset\ikon-Users-putih.png">    </p:cNvPr>
+          <p:cNvPr id="44" name="Image 0" descr="C:\laragon\www\e-commerce\scripts\ppt\aset\ikon-Users-putih.png">    </p:cNvPr>
           <p:cNvPicPr>
             <a:picLocks noChangeAspect="1"/>
           </p:cNvPicPr>
@@ -10367,7 +10367,7 @@
       </p:sp>
       <p:pic>
         <p:nvPicPr>
-          <p:cNvPr id="48" name="Image 1" descr="C:\Users\Ilham\AppData\Local\Temp\claude\C--laragon-www-e-commerce\f9bd3d3e-d07a-4d63-a45c-a6ddd58be178\scratchpad\deck\aset\ikon-GitBranch-putih.png">    </p:cNvPr>
+          <p:cNvPr id="48" name="Image 1" descr="C:\laragon\www\e-commerce\scripts\ppt\aset\ikon-GitBranch-putih.png">    </p:cNvPr>
           <p:cNvPicPr>
             <a:picLocks noChangeAspect="1"/>
           </p:cNvPicPr>
@@ -10489,7 +10489,7 @@
       </p:sp>
       <p:pic>
         <p:nvPicPr>
-          <p:cNvPr id="52" name="Image 2" descr="C:\Users\Ilham\AppData\Local\Temp\claude\C--laragon-www-e-commerce\f9bd3d3e-d07a-4d63-a45c-a6ddd58be178\scratchpad\deck\aset\ikon-BadgeCheck-putih.png">    </p:cNvPr>
+          <p:cNvPr id="52" name="Image 2" descr="C:\laragon\www\e-commerce\scripts\ppt\aset\ikon-BadgeCheck-putih.png">    </p:cNvPr>
           <p:cNvPicPr>
             <a:picLocks noChangeAspect="1"/>
           </p:cNvPicPr>
@@ -10958,7 +10958,7 @@
                 <a:ea typeface="Segoe UI Semibold" pitchFamily="34" charset="-122"/>
                 <a:cs typeface="Segoe UI Semibold" pitchFamily="34" charset="-120"/>
               </a:rPr>
-              <a:t>459</a:t>
+              <a:t>475</a:t>
             </a:r>
             <a:endParaRPr lang="en-US" sz="4800" dirty="0"/>
           </a:p>
@@ -11097,7 +11097,7 @@
                 <a:ea typeface="Segoe UI Semibold" pitchFamily="34" charset="-122"/>
                 <a:cs typeface="Segoe UI Semibold" pitchFamily="34" charset="-120"/>
               </a:rPr>
-              <a:t>86</a:t>
+              <a:t>87</a:t>
             </a:r>
             <a:endParaRPr lang="en-US" sz="4800" dirty="0"/>
           </a:p>
@@ -11431,7 +11431,7 @@
                 <a:ea typeface="Segoe UI" pitchFamily="34" charset="-122"/>
                 <a:cs typeface="Segoe UI" pitchFamily="34" charset="-120"/>
               </a:rPr>
-              <a:t>Beranda 1,7 dtk ✓ · katalog 3,4 dtk (simulasi HP lambat) masih di atas target</a:t>
+              <a:t>Beranda 1,7 · katalog 2,3 · detail 2,2 dtk (HP diperlambat) ✓</a:t>
             </a:r>
             <a:endParaRPr lang="en-US" sz="1100" dirty="0"/>
           </a:p>
@@ -11890,7 +11890,7 @@
       </p:sp>
       <p:pic>
         <p:nvPicPr>
-          <p:cNvPr id="7" name="Image 0" descr="C:\Users\Ilham\AppData\Local\Temp\claude\C--laragon-www-e-commerce\f9bd3d3e-d07a-4d63-a45c-a6ddd58be178\scratchpad\deck\aset\ikon-ShieldCheck-putih.png">    </p:cNvPr>
+          <p:cNvPr id="7" name="Image 0" descr="C:\laragon\www\e-commerce\scripts\ppt\aset\ikon-ShieldCheck-putih.png">    </p:cNvPr>
           <p:cNvPicPr>
             <a:picLocks noChangeAspect="1"/>
           </p:cNvPicPr>
@@ -12119,7 +12119,7 @@
       </p:sp>
       <p:pic>
         <p:nvPicPr>
-          <p:cNvPr id="13" name="Image 1" descr="C:\Users\Ilham\AppData\Local\Temp\claude\C--laragon-www-e-commerce\f9bd3d3e-d07a-4d63-a45c-a6ddd58be178\scratchpad\deck\aset\ikon-Lock-putih.png">    </p:cNvPr>
+          <p:cNvPr id="13" name="Image 1" descr="C:\laragon\www\e-commerce\scripts\ppt\aset\ikon-Lock-putih.png">    </p:cNvPr>
           <p:cNvPicPr>
             <a:picLocks noChangeAspect="1"/>
           </p:cNvPicPr>
@@ -12348,7 +12348,7 @@
       </p:sp>
       <p:pic>
         <p:nvPicPr>
-          <p:cNvPr id="19" name="Image 2" descr="C:\Users\Ilham\AppData\Local\Temp\claude\C--laragon-www-e-commerce\f9bd3d3e-d07a-4d63-a45c-a6ddd58be178\scratchpad\deck\aset\ikon-Scale-putih.png">    </p:cNvPr>
+          <p:cNvPr id="19" name="Image 2" descr="C:\laragon\www\e-commerce\scripts\ppt\aset\ikon-Scale-putih.png">    </p:cNvPr>
           <p:cNvPicPr>
             <a:picLocks noChangeAspect="1"/>
           </p:cNvPicPr>
@@ -12577,7 +12577,7 @@
       </p:sp>
       <p:pic>
         <p:nvPicPr>
-          <p:cNvPr id="25" name="Image 3" descr="C:\Users\Ilham\AppData\Local\Temp\claude\C--laragon-www-e-commerce\f9bd3d3e-d07a-4d63-a45c-a6ddd58be178\scratchpad\deck\aset\ikon-Bot-hitam.png">    </p:cNvPr>
+          <p:cNvPr id="25" name="Image 3" descr="C:\laragon\www\e-commerce\scripts\ppt\aset\ikon-Bot-hitam.png">    </p:cNvPr>
           <p:cNvPicPr>
             <a:picLocks noChangeAspect="1"/>
           </p:cNvPicPr>
@@ -15706,7 +15706,7 @@
                           <a:ea typeface="Segoe UI" pitchFamily="34" charset="-122"/>
                           <a:cs typeface="Segoe UI" pitchFamily="34" charset="-120"/>
                         </a:rPr>
-                        <a:t>Backup MySQL dan uji restore</a:t>
+                        <a:t>Backup harian terenkripsi, simpan 30 hari, uji restore</a:t>
                       </a:r>
                       <a:endParaRPr lang="en-US" sz="1100" dirty="0">
                         <a:latin typeface="Segoe UI" charset="0"/>
@@ -15771,7 +15771,7 @@
                           <a:ea typeface="Segoe UI" pitchFamily="34" charset="-122"/>
                           <a:cs typeface="Segoe UI" pitchFamily="34" charset="-120"/>
                         </a:rPr>
-                        <a:t>Backup manual teruji; jadwal otomatis menyusul</a:t>
+                        <a:t>Backup otomatis berjalan; restore manual teruji</a:t>
                       </a:r>
                       <a:endParaRPr lang="en-US" sz="1100" dirty="0">
                         <a:latin typeface="Segoe UI" charset="0"/>
@@ -16709,7 +16709,7 @@
       </p:sp>
       <p:pic>
         <p:nvPicPr>
-          <p:cNvPr id="27" name="Image 0" descr="C:\Users\Ilham\AppData\Local\Temp\claude\C--laragon-www-e-commerce\f9bd3d3e-d07a-4d63-a45c-a6ddd58be178\scratchpad\deck\aset\ikon-Rocket-hitam.png">    </p:cNvPr>
+          <p:cNvPr id="27" name="Image 0" descr="C:\laragon\www\e-commerce\scripts\ppt\aset\ikon-Rocket-hitam.png">    </p:cNvPr>
           <p:cNvPicPr>
             <a:picLocks noChangeAspect="1"/>
           </p:cNvPicPr>
@@ -16831,7 +16831,7 @@
       </p:sp>
       <p:pic>
         <p:nvPicPr>
-          <p:cNvPr id="31" name="Image 1" descr="C:\Users\Ilham\AppData\Local\Temp\claude\C--laragon-www-e-commerce\f9bd3d3e-d07a-4d63-a45c-a6ddd58be178\scratchpad\deck\aset\ikon-Database-hitam.png">    </p:cNvPr>
+          <p:cNvPr id="31" name="Image 1" descr="C:\laragon\www\e-commerce\scripts\ppt\aset\ikon-Database-hitam.png">    </p:cNvPr>
           <p:cNvPicPr>
             <a:picLocks noChangeAspect="1"/>
           </p:cNvPicPr>
@@ -16925,7 +16925,7 @@
                 <a:ea typeface="Segoe UI" pitchFamily="34" charset="-122"/>
                 <a:cs typeface="Segoe UI" pitchFamily="34" charset="-120"/>
               </a:rPr>
-              <a:t>TLS terverifikasi; backup manual teruji</a:t>
+              <a:t>TLS terverifikasi; backup harian terenkripsi</a:t>
             </a:r>
             <a:endParaRPr lang="en-US" sz="1100" dirty="0"/>
           </a:p>
@@ -16953,7 +16953,7 @@
       </p:sp>
       <p:pic>
         <p:nvPicPr>
-          <p:cNvPr id="35" name="Image 2" descr="C:\Users\Ilham\AppData\Local\Temp\claude\C--laragon-www-e-commerce\f9bd3d3e-d07a-4d63-a45c-a6ddd58be178\scratchpad\deck\aset\ikon-CreditCard-hitam.png">    </p:cNvPr>
+          <p:cNvPr id="35" name="Image 2" descr="C:\laragon\www\e-commerce\scripts\ppt\aset\ikon-CreditCard-hitam.png">    </p:cNvPr>
           <p:cNvPicPr>
             <a:picLocks noChangeAspect="1"/>
           </p:cNvPicPr>
@@ -17047,7 +17047,7 @@
                 <a:ea typeface="Segoe UI" pitchFamily="34" charset="-122"/>
                 <a:cs typeface="Segoe UI" pitchFamily="34" charset="-120"/>
               </a:rPr>
-              <a:t>BCA &amp; Mandiri lunas; QRIS tertunda di simulator</a:t>
+              <a:t>Diuji di situs online: BCA lunas otomatis via webhook</a:t>
             </a:r>
             <a:endParaRPr lang="en-US" sz="1100" dirty="0"/>
           </a:p>
@@ -17075,7 +17075,7 @@
       </p:sp>
       <p:pic>
         <p:nvPicPr>
-          <p:cNvPr id="39" name="Image 3" descr="C:\Users\Ilham\AppData\Local\Temp\claude\C--laragon-www-e-commerce\f9bd3d3e-d07a-4d63-a45c-a6ddd58be178\scratchpad\deck\aset\ikon-Mail-hitam.png">    </p:cNvPr>
+          <p:cNvPr id="39" name="Image 3" descr="C:\laragon\www\e-commerce\scripts\ppt\aset\ikon-Mail-hitam.png">    </p:cNvPr>
           <p:cNvPicPr>
             <a:picLocks noChangeAspect="1"/>
           </p:cNvPicPr>
@@ -17169,7 +17169,7 @@
                 <a:ea typeface="Segoe UI" pitchFamily="34" charset="-122"/>
                 <a:cs typeface="Segoe UI" pitchFamily="34" charset="-120"/>
               </a:rPr>
-              <a:t>Email invoice &amp; reset, unggah gambar</a:t>
+              <a:t>Email di latar; gambar lama ikut terhapus</a:t>
             </a:r>
             <a:endParaRPr lang="en-US" sz="1100" dirty="0"/>
           </a:p>
@@ -17197,7 +17197,7 @@
       </p:sp>
       <p:pic>
         <p:nvPicPr>
-          <p:cNvPr id="43" name="Image 4" descr="C:\Users\Ilham\AppData\Local\Temp\claude\C--laragon-www-e-commerce\f9bd3d3e-d07a-4d63-a45c-a6ddd58be178\scratchpad\deck\aset\ikon-Globe-hitam.png">    </p:cNvPr>
+          <p:cNvPr id="43" name="Image 4" descr="C:\laragon\www\e-commerce\scripts\ppt\aset\ikon-Globe-hitam.png">    </p:cNvPr>
           <p:cNvPicPr>
             <a:picLocks noChangeAspect="1"/>
           </p:cNvPicPr>
@@ -19058,7 +19058,7 @@
       </p:sp>
       <p:pic>
         <p:nvPicPr>
-          <p:cNvPr id="7" name="Image 0" descr="C:\Users\Ilham\AppData\Local\Temp\claude\C--laragon-www-e-commerce\f9bd3d3e-d07a-4d63-a45c-a6ddd58be178\scratchpad\deck\aset\ikon-User-putih.png">    </p:cNvPr>
+          <p:cNvPr id="7" name="Image 0" descr="C:\laragon\www\e-commerce\scripts\ppt\aset\ikon-User-putih.png">    </p:cNvPr>
           <p:cNvPicPr>
             <a:picLocks noChangeAspect="1"/>
           </p:cNvPicPr>
@@ -19436,7 +19436,7 @@
       </p:sp>
       <p:pic>
         <p:nvPicPr>
-          <p:cNvPr id="18" name="Image 1" descr="C:\Users\Ilham\AppData\Local\Temp\claude\C--laragon-www-e-commerce\f9bd3d3e-d07a-4d63-a45c-a6ddd58be178\scratchpad\deck\aset\ikon-UserCog-putih.png">    </p:cNvPr>
+          <p:cNvPr id="18" name="Image 1" descr="C:\laragon\www\e-commerce\scripts\ppt\aset\ikon-UserCog-putih.png">    </p:cNvPr>
           <p:cNvPicPr>
             <a:picLocks noChangeAspect="1"/>
           </p:cNvPicPr>
@@ -20922,7 +20922,7 @@
       </p:sp>
       <p:pic>
         <p:nvPicPr>
-          <p:cNvPr id="7" name="Image 0" descr="C:\Users\Ilham\AppData\Local\Temp\claude\C--laragon-www-e-commerce\f9bd3d3e-d07a-4d63-a45c-a6ddd58be178\scratchpad\deck\aset\ikon-Layers-putih.png">    </p:cNvPr>
+          <p:cNvPr id="7" name="Image 0" descr="C:\laragon\www\e-commerce\scripts\ppt\aset\ikon-Layers-putih.png">    </p:cNvPr>
           <p:cNvPicPr>
             <a:picLocks noChangeAspect="1"/>
           </p:cNvPicPr>
@@ -21066,7 +21066,7 @@
       </p:sp>
       <p:pic>
         <p:nvPicPr>
-          <p:cNvPr id="12" name="Image 1" descr="C:\Users\Ilham\AppData\Local\Temp\claude\C--laragon-www-e-commerce\f9bd3d3e-d07a-4d63-a45c-a6ddd58be178\scratchpad\deck\aset\ikon-Database-putih.png">    </p:cNvPr>
+          <p:cNvPr id="12" name="Image 1" descr="C:\laragon\www\e-commerce\scripts\ppt\aset\ikon-Database-putih.png">    </p:cNvPr>
           <p:cNvPicPr>
             <a:picLocks noChangeAspect="1"/>
           </p:cNvPicPr>
@@ -21210,7 +21210,7 @@
       </p:sp>
       <p:pic>
         <p:nvPicPr>
-          <p:cNvPr id="17" name="Image 2" descr="C:\Users\Ilham\AppData\Local\Temp\claude\C--laragon-www-e-commerce\f9bd3d3e-d07a-4d63-a45c-a6ddd58be178\scratchpad\deck\aset\ikon-Workflow-putih.png">    </p:cNvPr>
+          <p:cNvPr id="17" name="Image 2" descr="C:\laragon\www\e-commerce\scripts\ppt\aset\ikon-Workflow-putih.png">    </p:cNvPr>
           <p:cNvPicPr>
             <a:picLocks noChangeAspect="1"/>
           </p:cNvPicPr>
@@ -21354,7 +21354,7 @@
       </p:sp>
       <p:pic>
         <p:nvPicPr>
-          <p:cNvPr id="22" name="Image 3" descr="C:\Users\Ilham\AppData\Local\Temp\claude\C--laragon-www-e-commerce\f9bd3d3e-d07a-4d63-a45c-a6ddd58be178\scratchpad\deck\aset\ikon-Palette-putih.png">    </p:cNvPr>
+          <p:cNvPr id="22" name="Image 3" descr="C:\laragon\www\e-commerce\scripts\ppt\aset\ikon-Palette-putih.png">    </p:cNvPr>
           <p:cNvPicPr>
             <a:picLocks noChangeAspect="1"/>
           </p:cNvPicPr>
@@ -21498,7 +21498,7 @@
       </p:sp>
       <p:pic>
         <p:nvPicPr>
-          <p:cNvPr id="27" name="Image 4" descr="C:\Users\Ilham\AppData\Local\Temp\claude\C--laragon-www-e-commerce\f9bd3d3e-d07a-4d63-a45c-a6ddd58be178\scratchpad\deck\aset\ikon-ShoppingCart-putih.png">    </p:cNvPr>
+          <p:cNvPr id="27" name="Image 4" descr="C:\laragon\www\e-commerce\scripts\ppt\aset\ikon-ShoppingCart-putih.png">    </p:cNvPr>
           <p:cNvPicPr>
             <a:picLocks noChangeAspect="1"/>
           </p:cNvPicPr>
@@ -21642,7 +21642,7 @@
       </p:sp>
       <p:pic>
         <p:nvPicPr>
-          <p:cNvPr id="32" name="Image 5" descr="C:\Users\Ilham\AppData\Local\Temp\claude\C--laragon-www-e-commerce\f9bd3d3e-d07a-4d63-a45c-a6ddd58be178\scratchpad\deck\aset\ikon-ListChecks-putih.png">    </p:cNvPr>
+          <p:cNvPr id="32" name="Image 5" descr="C:\laragon\www\e-commerce\scripts\ppt\aset\ikon-ListChecks-putih.png">    </p:cNvPr>
           <p:cNvPicPr>
             <a:picLocks noChangeAspect="1"/>
           </p:cNvPicPr>
@@ -21786,7 +21786,7 @@
       </p:sp>
       <p:pic>
         <p:nvPicPr>
-          <p:cNvPr id="37" name="Image 6" descr="C:\Users\Ilham\AppData\Local\Temp\claude\C--laragon-www-e-commerce\f9bd3d3e-d07a-4d63-a45c-a6ddd58be178\scratchpad\deck\aset\ikon-KeyRound-putih.png">    </p:cNvPr>
+          <p:cNvPr id="37" name="Image 6" descr="C:\laragon\www\e-commerce\scripts\ppt\aset\ikon-KeyRound-putih.png">    </p:cNvPr>
           <p:cNvPicPr>
             <a:picLocks noChangeAspect="1"/>
           </p:cNvPicPr>
@@ -21930,7 +21930,7 @@
       </p:sp>
       <p:pic>
         <p:nvPicPr>
-          <p:cNvPr id="42" name="Image 7" descr="C:\Users\Ilham\AppData\Local\Temp\claude\C--laragon-www-e-commerce\f9bd3d3e-d07a-4d63-a45c-a6ddd58be178\scratchpad\deck\aset\ikon-CreditCard-putih.png">    </p:cNvPr>
+          <p:cNvPr id="42" name="Image 7" descr="C:\laragon\www\e-commerce\scripts\ppt\aset\ikon-CreditCard-putih.png">    </p:cNvPr>
           <p:cNvPicPr>
             <a:picLocks noChangeAspect="1"/>
           </p:cNvPicPr>
@@ -22074,7 +22074,7 @@
       </p:sp>
       <p:pic>
         <p:nvPicPr>
-          <p:cNvPr id="47" name="Image 8" descr="C:\Users\Ilham\AppData\Local\Temp\claude\C--laragon-www-e-commerce\f9bd3d3e-d07a-4d63-a45c-a6ddd58be178\scratchpad\deck\aset\ikon-Sparkles-putih.png">    </p:cNvPr>
+          <p:cNvPr id="47" name="Image 8" descr="C:\laragon\www\e-commerce\scripts\ppt\aset\ikon-Sparkles-putih.png">    </p:cNvPr>
           <p:cNvPicPr>
             <a:picLocks noChangeAspect="1"/>
           </p:cNvPicPr>
@@ -22432,7 +22432,7 @@
       </p:sp>
       <p:pic>
         <p:nvPicPr>
-          <p:cNvPr id="8" name="Image 0" descr="C:\Users\Ilham\AppData\Local\Temp\claude\C--laragon-www-e-commerce\f9bd3d3e-d07a-4d63-a45c-a6ddd58be178\scratchpad\deck\aset\ikon-User-putih.png">    </p:cNvPr>
+          <p:cNvPr id="8" name="Image 0" descr="C:\laragon\www\e-commerce\scripts\ppt\aset\ikon-User-putih.png">    </p:cNvPr>
           <p:cNvPicPr>
             <a:picLocks noChangeAspect="1"/>
           </p:cNvPicPr>
@@ -22515,7 +22515,7 @@
       </p:sp>
       <p:pic>
         <p:nvPicPr>
-          <p:cNvPr id="11" name="Image 1" descr="C:\Users\Ilham\AppData\Local\Temp\claude\C--laragon-www-e-commerce\f9bd3d3e-d07a-4d63-a45c-a6ddd58be178\scratchpad\deck\aset\ikon-UserCog-putih.png">    </p:cNvPr>
+          <p:cNvPr id="11" name="Image 1" descr="C:\laragon\www\e-commerce\scripts\ppt\aset\ikon-UserCog-putih.png">    </p:cNvPr>
           <p:cNvPicPr>
             <a:picLocks noChangeAspect="1"/>
           </p:cNvPicPr>
@@ -23002,7 +23002,7 @@
       </p:sp>
       <p:pic>
         <p:nvPicPr>
-          <p:cNvPr id="26" name="Image 2" descr="C:\Users\Ilham\AppData\Local\Temp\claude\C--laragon-www-e-commerce\f9bd3d3e-d07a-4d63-a45c-a6ddd58be178\scratchpad\deck\aset\ikon-Database-putih.png">    </p:cNvPr>
+          <p:cNvPr id="26" name="Image 2" descr="C:\laragon\www\e-commerce\scripts\ppt\aset\ikon-Database-putih.png">    </p:cNvPr>
           <p:cNvPicPr>
             <a:picLocks noChangeAspect="1"/>
           </p:cNvPicPr>
@@ -23224,7 +23224,7 @@
       </p:sp>
       <p:pic>
         <p:nvPicPr>
-          <p:cNvPr id="33" name="Image 3" descr="C:\Users\Ilham\AppData\Local\Temp\claude\C--laragon-www-e-commerce\f9bd3d3e-d07a-4d63-a45c-a6ddd58be178\scratchpad\deck\aset\ikon-Image-putih.png">    </p:cNvPr>
+          <p:cNvPr id="33" name="Image 3" descr="C:\laragon\www\e-commerce\scripts\ppt\aset\ikon-Image-putih.png">    </p:cNvPr>
           <p:cNvPicPr>
             <a:picLocks noChangeAspect="1"/>
           </p:cNvPicPr>
@@ -23368,7 +23368,7 @@
       </p:sp>
       <p:pic>
         <p:nvPicPr>
-          <p:cNvPr id="38" name="Image 4" descr="C:\Users\Ilham\AppData\Local\Temp\claude\C--laragon-www-e-commerce\f9bd3d3e-d07a-4d63-a45c-a6ddd58be178\scratchpad\deck\aset\ikon-Mail-putih.png">    </p:cNvPr>
+          <p:cNvPr id="38" name="Image 4" descr="C:\laragon\www\e-commerce\scripts\ppt\aset\ikon-Mail-putih.png">    </p:cNvPr>
           <p:cNvPicPr>
             <a:picLocks noChangeAspect="1"/>
           </p:cNvPicPr>
@@ -23512,7 +23512,7 @@
       </p:sp>
       <p:pic>
         <p:nvPicPr>
-          <p:cNvPr id="43" name="Image 5" descr="C:\Users\Ilham\AppData\Local\Temp\claude\C--laragon-www-e-commerce\f9bd3d3e-d07a-4d63-a45c-a6ddd58be178\scratchpad\deck\aset\ikon-CreditCard-putih.png">    </p:cNvPr>
+          <p:cNvPr id="43" name="Image 5" descr="C:\laragon\www\e-commerce\scripts\ppt\aset\ikon-CreditCard-putih.png">    </p:cNvPr>
           <p:cNvPicPr>
             <a:picLocks noChangeAspect="1"/>
           </p:cNvPicPr>
@@ -23656,7 +23656,7 @@
       </p:sp>
       <p:pic>
         <p:nvPicPr>
-          <p:cNvPr id="48" name="Image 6" descr="C:\Users\Ilham\AppData\Local\Temp\claude\C--laragon-www-e-commerce\f9bd3d3e-d07a-4d63-a45c-a6ddd58be178\scratchpad\deck\aset\ikon-Clock-putih.png">    </p:cNvPr>
+          <p:cNvPr id="48" name="Image 6" descr="C:\laragon\www\e-commerce\scripts\ppt\aset\ikon-Clock-putih.png">    </p:cNvPr>
           <p:cNvPicPr>
             <a:picLocks noChangeAspect="1"/>
           </p:cNvPicPr>
@@ -23711,7 +23711,7 @@
                 <a:ea typeface="Segoe UI Semibold" pitchFamily="34" charset="-122"/>
                 <a:cs typeface="Segoe UI Semibold" pitchFamily="34" charset="-120"/>
               </a:rPr>
-              <a:t>Vercel Cron</a:t>
+              <a:t>Cron &amp; backup</a:t>
             </a:r>
             <a:endParaRPr lang="en-US" sz="1200" dirty="0"/>
           </a:p>
@@ -23750,7 +23750,7 @@
                 <a:ea typeface="Segoe UI" pitchFamily="34" charset="-122"/>
                 <a:cs typeface="Segoe UI" pitchFamily="34" charset="-120"/>
               </a:rPr>
-              <a:t>Batal/selesai otomatis</a:t>
+              <a:t>Pesanan tiap jam, backup harian</a:t>
             </a:r>
             <a:endParaRPr lang="en-US" sz="950" dirty="0"/>
           </a:p>
@@ -23800,7 +23800,7 @@
       </p:sp>
       <p:pic>
         <p:nvPicPr>
-          <p:cNvPr id="53" name="Image 7" descr="C:\Users\Ilham\AppData\Local\Temp\claude\C--laragon-www-e-commerce\f9bd3d3e-d07a-4d63-a45c-a6ddd58be178\scratchpad\deck\aset\ikon-Bot-putih.png">    </p:cNvPr>
+          <p:cNvPr id="53" name="Image 7" descr="C:\laragon\www\e-commerce\scripts\ppt\aset\ikon-Bot-putih.png">    </p:cNvPr>
           <p:cNvPicPr>
             <a:picLocks noChangeAspect="1"/>
           </p:cNvPicPr>
@@ -26210,7 +26210,7 @@
       </p:sp>
       <p:pic>
         <p:nvPicPr>
-          <p:cNvPr id="35" name="Image 0" descr="C:\Users\Ilham\AppData\Local\Temp\claude\C--laragon-www-e-commerce\f9bd3d3e-d07a-4d63-a45c-a6ddd58be178\scratchpad\deck\aset\ikon-Ban-putih.png">    </p:cNvPr>
+          <p:cNvPr id="35" name="Image 0" descr="C:\laragon\www\e-commerce\scripts\ppt\aset\ikon-Ban-putih.png">    </p:cNvPr>
           <p:cNvPicPr>
             <a:picLocks noChangeAspect="1"/>
           </p:cNvPicPr>
@@ -26354,7 +26354,7 @@
       </p:sp>
       <p:pic>
         <p:nvPicPr>
-          <p:cNvPr id="40" name="Image 1" descr="C:\Users\Ilham\AppData\Local\Temp\claude\C--laragon-www-e-commerce\f9bd3d3e-d07a-4d63-a45c-a6ddd58be178\scratchpad\deck\aset\ikon-Scale-putih.png">    </p:cNvPr>
+          <p:cNvPr id="40" name="Image 1" descr="C:\laragon\www\e-commerce\scripts\ppt\aset\ikon-Scale-putih.png">    </p:cNvPr>
           <p:cNvPicPr>
             <a:picLocks noChangeAspect="1"/>
           </p:cNvPicPr>
@@ -26498,7 +26498,7 @@
       </p:sp>
       <p:pic>
         <p:nvPicPr>
-          <p:cNvPr id="45" name="Image 2" descr="C:\Users\Ilham\AppData\Local\Temp\claude\C--laragon-www-e-commerce\f9bd3d3e-d07a-4d63-a45c-a6ddd58be178\scratchpad\deck\aset\ikon-ListChecks-putih.png">    </p:cNvPr>
+          <p:cNvPr id="45" name="Image 2" descr="C:\laragon\www\e-commerce\scripts\ppt\aset\ikon-ListChecks-putih.png">    </p:cNvPr>
           <p:cNvPicPr>
             <a:picLocks noChangeAspect="1"/>
           </p:cNvPicPr>

</xml_diff>

<commit_message>
docs: rilis fitur lanjutan D19-D21, PPT diperbarui, label kurir admin
</commit_message>
<xml_diff>
--- a/docs/Presentasi_ECommerce_TokoKita.pptx
+++ b/docs/Presentasi_ECommerce_TokoKita.pptx
@@ -128,20 +128,20 @@
   <p:extLst>
     <p:ext uri="{521415D9-36F7-43E2-AB2F-B90AF26B5E84}">
       <p14:sectionLst xmlns:p14="http://schemas.microsoft.com/office/powerpoint/2010/main">
-        <p14:section name="Pembuka" id="{fa386766-66da-469e-d389-5603a2491031}">
+        <p14:section name="Pembuka" id="{28aba80d-21c9-9da8-1152-ed4cf3748a47}">
           <p14:sldIdLst>
             <p14:sldId id="256"/>
             <p14:sldId id="257"/>
           </p14:sldIdLst>
         </p14:section>
-        <p14:section name="Latar &amp; cakupan" id="{18e4b738-7b82-aff7-76b9-f296970f0df6}">
+        <p14:section name="Latar &amp; cakupan" id="{0c3f99bc-29db-75d1-9d9b-40653df43fe9}">
           <p14:sldIdLst>
             <p14:sldId id="258"/>
             <p14:sldId id="259"/>
             <p14:sldId id="260"/>
           </p14:sldIdLst>
         </p14:section>
-        <p14:section name="Teknologi" id="{98a0e16d-594d-64c1-6f20-c2f16d6e29e9}">
+        <p14:section name="Teknologi" id="{f7da6205-8369-c94c-d63e-2dfe88598a4f}">
           <p14:sldIdLst>
             <p14:sldId id="261"/>
             <p14:sldId id="262"/>
@@ -149,7 +149,7 @@
             <p14:sldId id="264"/>
           </p14:sldIdLst>
         </p14:section>
-        <p14:section name="Tampilan aplikasi" id="{c82735dc-affc-23eb-3e24-00bb38ebc43f}">
+        <p14:section name="Tampilan aplikasi" id="{ed409827-03ea-3e94-dc5b-2e03151c6622}">
           <p14:sldIdLst>
             <p14:sldId id="265"/>
             <p14:sldId id="266"/>
@@ -159,13 +159,13 @@
             <p14:sldId id="270"/>
           </p14:sldIdLst>
         </p14:section>
-        <p14:section name="Tim &amp; cara kerja" id="{465eb0c1-af4e-ea75-43e8-56182a71af8d}">
+        <p14:section name="Tim &amp; cara kerja" id="{bf78a3af-7e8a-20a4-c47f-687eee35debb}">
           <p14:sldIdLst>
             <p14:sldId id="271"/>
             <p14:sldId id="272"/>
           </p14:sldIdLst>
         </p14:section>
-        <p14:section name="Kualitas &amp; demo" id="{e8f9dd73-7e07-e2a9-e472-83c03caee086}">
+        <p14:section name="Kualitas &amp; demo" id="{8fb4e372-1d0a-51ed-dce8-543c5d2f56ed}">
           <p14:sldIdLst>
             <p14:sldId id="273"/>
             <p14:sldId id="274"/>
@@ -173,7 +173,7 @@
             <p14:sldId id="276"/>
           </p14:sldIdLst>
         </p14:section>
-        <p14:section name="Penutup" id="{9bf40b0c-fdf7-7617-8ddb-699a9e7138db}">
+        <p14:section name="Penutup" id="{71e7e6ac-fb33-ca38-eefa-9b4330c9f8a0}">
           <p14:sldIdLst>
             <p14:sldId id="277"/>
           </p14:sldIdLst>
@@ -1462,7 +1462,7 @@
           <a:p>
             <a:r>
               <a:rPr lang="en-US" dirty="0"/>
-              <a:t>Kepatuhan UU PDP, keamanan akun dengan Argon2id dan pembatasan percobaan, aturan transaksi yang adil, dan pengaman asisten AI.</a:t>
+              <a:t>Kepatuhan UU PDP, keamanan akun dengan Argon2id dan pembatasan percobaan, Login Google dengan OAuth + PKCE (admin tetap wajib password), aturan transaksi yang adil, dan pengaman asisten AI.</a:t>
             </a:r>
             <a:endParaRPr lang="en-US" dirty="0"/>
           </a:p>
@@ -2078,7 +2078,7 @@
           <a:p>
             <a:r>
               <a:rPr lang="en-US" dirty="0"/>
-              <a:t>Seluruh fitur MVP dan fitur lanjutan sudah jalan. Tambahan dari rencana awal: pembayaran sandbox, mode gelap, asisten AI, pilihan yang bisa dicari. Yang di luar cakupan sengaja tidak dikerjakan.</a:t>
+              <a:t>Seluruh fitur MVP dan fitur lanjutan sudah jalan. Tambahan dari rencana awal: pembayaran sandbox, mode gelap, asisten AI, ongkir per zona provinsi, Login Google, dan tombol cek resi di situs kurir. Lacak resi otomatis sudah dikodekan tetapi belum diaktifkan karena API-nya berbayar sekitar Rp 15 per pengecekan.</a:t>
             </a:r>
             <a:endParaRPr lang="en-US" dirty="0"/>
           </a:p>
@@ -6267,7 +6267,7 @@
                 <a:ea typeface="Segoe UI" pitchFamily="34" charset="-122"/>
                 <a:cs typeface="Segoe UI" pitchFamily="34" charset="-120"/>
               </a:rPr>
-              <a:t>JNE, SiCepat, GoSend dari total berat.</a:t>
+              <a:t>Dari total berat dan zona provinsi tujuan.</a:t>
             </a:r>
             <a:endParaRPr lang="en-US" sz="1200" dirty="0"/>
           </a:p>
@@ -10958,7 +10958,7 @@
                 <a:ea typeface="Segoe UI Semibold" pitchFamily="34" charset="-122"/>
                 <a:cs typeface="Segoe UI Semibold" pitchFamily="34" charset="-120"/>
               </a:rPr>
-              <a:t>475</a:t>
+              <a:t>551</a:t>
             </a:r>
             <a:endParaRPr lang="en-US" sz="4800" dirty="0"/>
           </a:p>
@@ -11036,7 +11036,7 @@
                 <a:ea typeface="Segoe UI" pitchFamily="34" charset="-122"/>
                 <a:cs typeface="Segoe UI" pitchFamily="34" charset="-120"/>
               </a:rPr>
-              <a:t>+ 30 tes integrasi MySQL</a:t>
+              <a:t>+ 34 tes integrasi MySQL</a:t>
             </a:r>
             <a:endParaRPr lang="en-US" sz="1100" dirty="0"/>
           </a:p>
@@ -11097,7 +11097,7 @@
                 <a:ea typeface="Segoe UI Semibold" pitchFamily="34" charset="-122"/>
                 <a:cs typeface="Segoe UI Semibold" pitchFamily="34" charset="-120"/>
               </a:rPr>
-              <a:t>87</a:t>
+              <a:t>88</a:t>
             </a:r>
             <a:endParaRPr lang="en-US" sz="4800" dirty="0"/>
           </a:p>
@@ -12256,7 +12256,7 @@
                 <a:ea typeface="Segoe UI" pitchFamily="34" charset="-122"/>
                 <a:cs typeface="Segoe UI" pitchFamily="34" charset="-120"/>
               </a:rPr>
-              <a:t>Password di-hash Argon2id</a:t>
+              <a:t>Argon2id + Login Google (PKCE)</a:t>
             </a:r>
             <a:endParaRPr lang="en-US" sz="1150" dirty="0"/>
           </a:p>
@@ -20483,7 +20483,7 @@
                 <a:ea typeface="Segoe UI" pitchFamily="34" charset="-122"/>
                 <a:cs typeface="Segoe UI" pitchFamily="34" charset="-120"/>
               </a:rPr>
-              <a:t>Pilihan bisa dicari</a:t>
+              <a:t>Ongkir per zona provinsi</a:t>
             </a:r>
             <a:endParaRPr lang="en-US" sz="1250" dirty="0"/>
           </a:p>
@@ -20504,7 +20504,28 @@
                 <a:ea typeface="Segoe UI" pitchFamily="34" charset="-122"/>
                 <a:cs typeface="Segoe UI" pitchFamily="34" charset="-120"/>
               </a:rPr>
-              <a:t>Konfirmasi keluar</a:t>
+              <a:t>Login Google</a:t>
+            </a:r>
+            <a:endParaRPr lang="en-US" sz="1250" dirty="0"/>
+          </a:p>
+          <a:p>
+            <a:pPr marL="342900" indent="-342900">
+              <a:spcAft>
+                <a:spcPts val="500"/>
+              </a:spcAft>
+              <a:buSzPct val="100000"/>
+              <a:buChar char="✓"/>
+            </a:pPr>
+            <a:r>
+              <a:rPr lang="en-US" sz="1250" dirty="0">
+                <a:solidFill>
+                  <a:srgbClr val="0A0A0A"/>
+                </a:solidFill>
+                <a:latin typeface="Segoe UI" pitchFamily="34" charset="0"/>
+                <a:ea typeface="Segoe UI" pitchFamily="34" charset="-122"/>
+                <a:cs typeface="Segoe UI" pitchFamily="34" charset="-120"/>
+              </a:rPr>
+              <a:t>Cek resi di situs kurir</a:t>
             </a:r>
             <a:endParaRPr lang="en-US" sz="1250" dirty="0"/>
           </a:p>
@@ -20634,7 +20655,7 @@
                 <a:ea typeface="Segoe UI" pitchFamily="34" charset="-122"/>
                 <a:cs typeface="Segoe UI" pitchFamily="34" charset="-120"/>
               </a:rPr>
-              <a:t>Ongkir per kota tujuan</a:t>
+              <a:t>Lacak resi otomatis (API berbayar, kode siap)</a:t>
             </a:r>
             <a:endParaRPr lang="en-US" sz="1250" dirty="0"/>
           </a:p>
@@ -20655,28 +20676,7 @@
                 <a:ea typeface="Segoe UI" pitchFamily="34" charset="-122"/>
                 <a:cs typeface="Segoe UI" pitchFamily="34" charset="-120"/>
               </a:rPr>
-              <a:t>Lacak resi otomatis</a:t>
-            </a:r>
-            <a:endParaRPr lang="en-US" sz="1250" dirty="0"/>
-          </a:p>
-          <a:p>
-            <a:pPr marL="342900" indent="-342900">
-              <a:spcAft>
-                <a:spcPts val="500"/>
-              </a:spcAft>
-              <a:buSzPct val="100000"/>
-              <a:buChar char="–"/>
-            </a:pPr>
-            <a:r>
-              <a:rPr lang="en-US" sz="1250" dirty="0">
-                <a:solidFill>
-                  <a:srgbClr val="5C5C5C"/>
-                </a:solidFill>
-                <a:latin typeface="Segoe UI" pitchFamily="34" charset="0"/>
-                <a:ea typeface="Segoe UI" pitchFamily="34" charset="-122"/>
-                <a:cs typeface="Segoe UI" pitchFamily="34" charset="-120"/>
-              </a:rPr>
-              <a:t>Login Google</a:t>
+              <a:t>Tarif ongkir resmi ekspedisi</a:t>
             </a:r>
             <a:endParaRPr lang="en-US" sz="1250" dirty="0"/>
           </a:p>

</xml_diff>

<commit_message>
docs: resi pesanan demo acak, hasil lacak hanya untuk resi asli
</commit_message>
<xml_diff>
--- a/docs/Presentasi_ECommerce_TokoKita.pptx
+++ b/docs/Presentasi_ECommerce_TokoKita.pptx
@@ -128,20 +128,20 @@
   <p:extLst>
     <p:ext uri="{521415D9-36F7-43E2-AB2F-B90AF26B5E84}">
       <p14:sectionLst xmlns:p14="http://schemas.microsoft.com/office/powerpoint/2010/main">
-        <p14:section name="Pembuka" id="{28aba80d-21c9-9da8-1152-ed4cf3748a47}">
+        <p14:section name="Pembuka" id="{ca71d5fe-8011-f885-3453-6895fd9ac184}">
           <p14:sldIdLst>
             <p14:sldId id="256"/>
             <p14:sldId id="257"/>
           </p14:sldIdLst>
         </p14:section>
-        <p14:section name="Latar &amp; cakupan" id="{0c3f99bc-29db-75d1-9d9b-40653df43fe9}">
+        <p14:section name="Latar &amp; cakupan" id="{cb25103f-cb9f-0225-3883-383bb6537afe}">
           <p14:sldIdLst>
             <p14:sldId id="258"/>
             <p14:sldId id="259"/>
             <p14:sldId id="260"/>
           </p14:sldIdLst>
         </p14:section>
-        <p14:section name="Teknologi" id="{f7da6205-8369-c94c-d63e-2dfe88598a4f}">
+        <p14:section name="Teknologi" id="{3cfd1fd1-a6c1-2059-82ae-6821cb78f94c}">
           <p14:sldIdLst>
             <p14:sldId id="261"/>
             <p14:sldId id="262"/>
@@ -149,7 +149,7 @@
             <p14:sldId id="264"/>
           </p14:sldIdLst>
         </p14:section>
-        <p14:section name="Tampilan aplikasi" id="{ed409827-03ea-3e94-dc5b-2e03151c6622}">
+        <p14:section name="Tampilan aplikasi" id="{23a555c4-3374-fccc-1290-d2977356de76}">
           <p14:sldIdLst>
             <p14:sldId id="265"/>
             <p14:sldId id="266"/>
@@ -159,13 +159,13 @@
             <p14:sldId id="270"/>
           </p14:sldIdLst>
         </p14:section>
-        <p14:section name="Tim &amp; cara kerja" id="{bf78a3af-7e8a-20a4-c47f-687eee35debb}">
+        <p14:section name="Tim &amp; cara kerja" id="{f3277d9b-9f17-baff-9583-6d8f87c491ad}">
           <p14:sldIdLst>
             <p14:sldId id="271"/>
             <p14:sldId id="272"/>
           </p14:sldIdLst>
         </p14:section>
-        <p14:section name="Kualitas &amp; demo" id="{8fb4e372-1d0a-51ed-dce8-543c5d2f56ed}">
+        <p14:section name="Kualitas &amp; demo" id="{ce3a716b-1aa4-ba51-b8de-f02924f69335}">
           <p14:sldIdLst>
             <p14:sldId id="273"/>
             <p14:sldId id="274"/>
@@ -173,7 +173,7 @@
             <p14:sldId id="276"/>
           </p14:sldIdLst>
         </p14:section>
-        <p14:section name="Penutup" id="{71e7e6ac-fb33-ca38-eefa-9b4330c9f8a0}">
+        <p14:section name="Penutup" id="{0487dc0d-450f-ae67-a0c7-612048087971}">
           <p14:sldIdLst>
             <p14:sldId id="277"/>
           </p14:sldIdLst>
@@ -2078,7 +2078,7 @@
           <a:p>
             <a:r>
               <a:rPr lang="en-US" dirty="0"/>
-              <a:t>Seluruh fitur MVP dan fitur lanjutan sudah jalan. Tambahan dari rencana awal: pembayaran sandbox, mode gelap, asisten AI, ongkir per zona provinsi, Login Google, dan tombol cek resi di situs kurir. Lacak resi otomatis sudah dikodekan tetapi belum diaktifkan karena API-nya berbayar sekitar Rp 15 per pengecekan.</a:t>
+              <a:t>Seluruh fitur MVP dan fitur lanjutan sudah jalan. Tambahan dari rencana awal: pembayaran sandbox, mode gelap, asisten AI, ongkir per zona provinsi, Login Google, dan tombol cek resi di situs kurir. Lacak resi otomatis sudah dikodekan tetapi belum diaktifkan karena API-nya berbayar sekitar Rp 15 per pengecekan. Resi di data demo dibuat acak, jadi situs kurir menjawab tidak ditemukan; hasil lacak muncul untuk resi kiriman asli.</a:t>
             </a:r>
             <a:endParaRPr lang="en-US" dirty="0"/>
           </a:p>

</xml_diff>

<commit_message>
docs: PPT slide tim memuat nama anggota dan ketua tim
Slide 17 sebelumnya hanya "Anggota 1-5". Nama dari pemilik diurutkan sesuai
A1-A5 di trello-board-plan.md; Azrian Dalimunthe ditandai sebagai ketua tim.
Nama lengkap juga ditambahkan ke tabel anggota di trello-board-plan.md.

Co-Authored-By: Claude <noreply@anthropic.com>
</commit_message>
<xml_diff>
--- a/docs/Presentasi_ECommerce_TokoKita.pptx
+++ b/docs/Presentasi_ECommerce_TokoKita.pptx
@@ -130,20 +130,20 @@
   <p:extLst>
     <p:ext uri="{521415D9-36F7-43E2-AB2F-B90AF26B5E84}">
       <p14:sectionLst xmlns:p14="http://schemas.microsoft.com/office/powerpoint/2010/main">
-        <p14:section name="Pembuka" id="{34193b1c-9af9-ae34-61da-940fc1fb15fc}">
+        <p14:section name="Pembuka" id="{451aff07-f60b-0a77-12a6-9b40f4f5bca2}">
           <p14:sldIdLst>
             <p14:sldId id="256"/>
             <p14:sldId id="257"/>
           </p14:sldIdLst>
         </p14:section>
-        <p14:section name="Latar &amp; cakupan" id="{33b0ad33-89d1-505a-b2ab-6658a5c68e7e}">
+        <p14:section name="Latar &amp; cakupan" id="{5cdfb406-09a2-a6f5-c1e0-aa9c7982ff3c}">
           <p14:sldIdLst>
             <p14:sldId id="258"/>
             <p14:sldId id="259"/>
             <p14:sldId id="260"/>
           </p14:sldIdLst>
         </p14:section>
-        <p14:section name="Teknologi" id="{ea2ab9b9-2a54-f381-ea49-d75e1e36c822}">
+        <p14:section name="Teknologi" id="{c1a145bb-0228-b14c-d838-9063a6463377}">
           <p14:sldIdLst>
             <p14:sldId id="261"/>
             <p14:sldId id="262"/>
@@ -152,7 +152,7 @@
             <p14:sldId id="265"/>
           </p14:sldIdLst>
         </p14:section>
-        <p14:section name="Tampilan aplikasi" id="{04c8e82a-79ac-1eb5-e990-549d0877099f}">
+        <p14:section name="Tampilan aplikasi" id="{ec0b39a4-d7d4-1504-be42-35b6a5257e9d}">
           <p14:sldIdLst>
             <p14:sldId id="266"/>
             <p14:sldId id="267"/>
@@ -162,13 +162,13 @@
             <p14:sldId id="271"/>
           </p14:sldIdLst>
         </p14:section>
-        <p14:section name="Tim &amp; cara kerja" id="{3d084203-9c8b-f257-0ab0-8ad09824d9f1}">
+        <p14:section name="Tim &amp; cara kerja" id="{c10989ec-7ced-8b84-a7ca-15608bbb1049}">
           <p14:sldIdLst>
             <p14:sldId id="272"/>
             <p14:sldId id="273"/>
           </p14:sldIdLst>
         </p14:section>
-        <p14:section name="Kualitas &amp; demo" id="{d17f5f66-96c3-fc3f-479e-f1128aa41016}">
+        <p14:section name="Kualitas &amp; demo" id="{81f8cd25-f27d-a66b-74a7-7db5405bd4cf}">
           <p14:sldIdLst>
             <p14:sldId id="274"/>
             <p14:sldId id="275"/>
@@ -177,7 +177,7 @@
             <p14:sldId id="278"/>
           </p14:sldIdLst>
         </p14:section>
-        <p14:section name="Penutup" id="{5d386b7a-d2b9-7d4f-0534-9d7611279d46}">
+        <p14:section name="Penutup" id="{be951a57-dd8f-6284-81fc-85d2263d1329}">
           <p14:sldIdLst>
             <p14:sldId id="279"/>
           </p14:sldIdLst>
@@ -1290,7 +1290,7 @@
           <a:p>
             <a:r>
               <a:rPr lang="en-US" dirty="0"/>
-              <a:t>Isi nama tiap anggota saat presentasi. Pembagian mengikuti modul PRD agar tiap orang punya area yang jelas dan jarang bentrok.</a:t>
+              <a:t>Azrian Dalimunthe memimpin tim sekaligus mengerjakan tampilan katalog. Pembagian mengikuti modul PRD agar tiap orang punya area yang jelas dan jarang bentrok; Kevin Ilham menjaga skema data dan meninjau setiap Pull Request sebelum digabung.</a:t>
             </a:r>
             <a:endParaRPr lang="en-US" dirty="0"/>
           </a:p>
@@ -9418,85 +9418,108 @@
         <p:spPr>
           <a:xfrm>
             <a:off x="804672" y="2697480"/>
-            <a:ext cx="1645920" cy="274320"/>
-          </a:xfrm>
-          <a:prstGeom prst="rect">
-            <a:avLst/>
-          </a:prstGeom>
-          <a:noFill/>
-          <a:ln/>
-        </p:spPr>
-        <p:txBody>
-          <a:bodyPr wrap="square" lIns="0" tIns="0" rIns="0" bIns="0" rtlCol="0" anchor="t"/>
-          <a:lstStyle/>
-          <a:p>
-            <a:pPr indent="0" marL="0">
-              <a:buNone/>
-            </a:pPr>
-            <a:r>
-              <a:rPr lang="en-US" sz="1150" dirty="0">
-                <a:solidFill>
-                  <a:srgbClr val="5C5C5C"/>
+            <a:ext cx="1691640" cy="621792"/>
+          </a:xfrm>
+          <a:prstGeom prst="rect">
+            <a:avLst/>
+          </a:prstGeom>
+          <a:noFill/>
+          <a:ln/>
+        </p:spPr>
+        <p:txBody>
+          <a:bodyPr wrap="square" lIns="0" tIns="0" rIns="0" bIns="0" rtlCol="0" anchor="b"/>
+          <a:lstStyle/>
+          <a:p>
+            <a:pPr indent="0" marL="0">
+              <a:buNone/>
+            </a:pPr>
+            <a:r>
+              <a:rPr lang="en-US" sz="1500" dirty="0">
+                <a:solidFill>
+                  <a:srgbClr val="0A0A0A"/>
+                </a:solidFill>
+                <a:latin typeface="Segoe UI Semibold" pitchFamily="34" charset="0"/>
+                <a:ea typeface="Segoe UI Semibold" pitchFamily="34" charset="-122"/>
+                <a:cs typeface="Segoe UI Semibold" pitchFamily="34" charset="-120"/>
+              </a:rPr>
+              <a:t>Kevin Ilham</a:t>
+            </a:r>
+            <a:endParaRPr lang="en-US" sz="1500" dirty="0"/>
+          </a:p>
+        </p:txBody>
+      </p:sp>
+      <p:sp>
+        <p:nvSpPr>
+          <p:cNvPr id="8" name="Text 6"/>
+          <p:cNvSpPr txBox="1"/>
+          <p:nvPr/>
+        </p:nvSpPr>
+        <p:spPr>
+          <a:xfrm>
+            <a:off x="804672" y="3383280"/>
+            <a:ext cx="1691640" cy="274320"/>
+          </a:xfrm>
+          <a:prstGeom prst="rect">
+            <a:avLst/>
+          </a:prstGeom>
+          <a:noFill/>
+          <a:ln/>
+        </p:spPr>
+        <p:txBody>
+          <a:bodyPr wrap="square" lIns="0" tIns="0" rIns="0" bIns="0" rtlCol="0" anchor="t"/>
+          <a:lstStyle/>
+          <a:p>
+            <a:pPr indent="0" marL="0">
+              <a:buNone/>
+            </a:pPr>
+            <a:r>
+              <a:rPr lang="en-US" sz="1200" dirty="0">
+                <a:solidFill>
+                  <a:srgbClr val="0A0A0A"/>
                 </a:solidFill>
                 <a:latin typeface="Segoe UI" pitchFamily="34" charset="0"/>
                 <a:ea typeface="Segoe UI" pitchFamily="34" charset="-122"/>
                 <a:cs typeface="Segoe UI" pitchFamily="34" charset="-120"/>
               </a:rPr>
-              <a:t>Anggota 1</a:t>
-            </a:r>
-            <a:endParaRPr lang="en-US" sz="1150" dirty="0"/>
-          </a:p>
-        </p:txBody>
-      </p:sp>
-      <p:sp>
-        <p:nvSpPr>
-          <p:cNvPr id="8" name="Text 6"/>
-          <p:cNvSpPr txBox="1"/>
-          <p:nvPr/>
-        </p:nvSpPr>
-        <p:spPr>
-          <a:xfrm>
-            <a:off x="804672" y="2971800"/>
-            <a:ext cx="1691640" cy="640080"/>
-          </a:xfrm>
-          <a:prstGeom prst="rect">
-            <a:avLst/>
-          </a:prstGeom>
-          <a:noFill/>
-          <a:ln/>
-        </p:spPr>
-        <p:txBody>
-          <a:bodyPr wrap="square" lIns="0" tIns="0" rIns="0" bIns="0" rtlCol="0" anchor="t"/>
-          <a:lstStyle/>
-          <a:p>
-            <a:pPr indent="0" marL="0">
-              <a:buNone/>
-            </a:pPr>
-            <a:r>
-              <a:rPr lang="en-US" sz="1500" dirty="0">
-                <a:solidFill>
-                  <a:srgbClr val="0A0A0A"/>
-                </a:solidFill>
-                <a:latin typeface="Segoe UI Semibold" pitchFamily="34" charset="0"/>
-                <a:ea typeface="Segoe UI Semibold" pitchFamily="34" charset="-122"/>
-                <a:cs typeface="Segoe UI Semibold" pitchFamily="34" charset="-120"/>
-              </a:rPr>
               <a:t>Arsitektur &amp; data</a:t>
             </a:r>
-            <a:endParaRPr lang="en-US" sz="1500" dirty="0"/>
-          </a:p>
-        </p:txBody>
-      </p:sp>
-      <p:sp>
-        <p:nvSpPr>
-          <p:cNvPr id="9" name="Text 7"/>
-          <p:cNvSpPr txBox="1"/>
-          <p:nvPr/>
-        </p:nvSpPr>
-        <p:spPr>
-          <a:xfrm>
-            <a:off x="804672" y="3749040"/>
-            <a:ext cx="1691640" cy="2011680"/>
+            <a:endParaRPr lang="en-US" sz="1200" dirty="0"/>
+          </a:p>
+        </p:txBody>
+      </p:sp>
+      <p:sp>
+        <p:nvSpPr>
+          <p:cNvPr id="9" name="Shape 7"/>
+          <p:cNvSpPr/>
+          <p:nvPr/>
+        </p:nvSpPr>
+        <p:spPr>
+          <a:xfrm>
+            <a:off x="804672" y="3794760"/>
+            <a:ext cx="1591056" cy="0"/>
+          </a:xfrm>
+          <a:prstGeom prst="line">
+            <a:avLst/>
+          </a:prstGeom>
+          <a:noFill/>
+          <a:ln w="12700">
+            <a:solidFill>
+              <a:srgbClr val="E6E6E6"/>
+            </a:solidFill>
+            <a:prstDash val="solid"/>
+          </a:ln>
+        </p:spPr>
+      </p:sp>
+      <p:sp>
+        <p:nvSpPr>
+          <p:cNvPr id="10" name="Text 8"/>
+          <p:cNvSpPr txBox="1"/>
+          <p:nvPr/>
+        </p:nvSpPr>
+        <p:spPr>
+          <a:xfrm>
+            <a:off x="804672" y="3977640"/>
+            <a:ext cx="1691640" cy="1828800"/>
           </a:xfrm>
           <a:prstGeom prst="rect">
             <a:avLst/>
@@ -9574,7 +9597,7 @@
       </p:sp>
       <p:sp>
         <p:nvSpPr>
-          <p:cNvPr id="10" name="Shape 8"/>
+          <p:cNvPr id="11" name="Shape 9"/>
           <p:cNvSpPr/>
           <p:nvPr/>
         </p:nvSpPr>
@@ -9589,14 +9612,14 @@
             </a:avLst>
           </a:prstGeom>
           <a:solidFill>
-            <a:srgbClr val="F3F3F3"/>
+            <a:srgbClr val="0A0A0A"/>
           </a:solidFill>
           <a:ln/>
         </p:spPr>
       </p:sp>
       <p:sp>
         <p:nvSpPr>
-          <p:cNvPr id="11" name="Text 9"/>
+          <p:cNvPr id="12" name="Text 10"/>
           <p:cNvSpPr txBox="1"/>
           <p:nvPr/>
         </p:nvSpPr>
@@ -9621,7 +9644,7 @@
             <a:r>
               <a:rPr lang="en-US" sz="2400" dirty="0">
                 <a:solidFill>
-                  <a:srgbClr val="5C5C5C"/>
+                  <a:srgbClr val="A3A3A3"/>
                 </a:solidFill>
                 <a:latin typeface="Segoe UI Semibold" pitchFamily="34" charset="0"/>
                 <a:ea typeface="Segoe UI Semibold" pitchFamily="34" charset="-122"/>
@@ -9635,92 +9658,176 @@
       </p:sp>
       <p:sp>
         <p:nvSpPr>
-          <p:cNvPr id="12" name="Text 10"/>
+          <p:cNvPr id="13" name="Shape 11"/>
+          <p:cNvSpPr/>
+          <p:nvPr/>
+        </p:nvSpPr>
+        <p:spPr>
+          <a:xfrm>
+            <a:off x="3566160" y="2194560"/>
+            <a:ext cx="1172261" cy="292608"/>
+          </a:xfrm>
+          <a:prstGeom prst="roundRect">
+            <a:avLst>
+              <a:gd name="adj" fmla="val 50000"/>
+            </a:avLst>
+          </a:prstGeom>
+          <a:solidFill>
+            <a:srgbClr val="262626"/>
+          </a:solidFill>
+          <a:ln/>
+        </p:spPr>
+      </p:sp>
+      <p:sp>
+        <p:nvSpPr>
+          <p:cNvPr id="14" name="Text 12"/>
+          <p:cNvSpPr txBox="1"/>
+          <p:nvPr/>
+        </p:nvSpPr>
+        <p:spPr>
+          <a:xfrm>
+            <a:off x="3566160" y="2194560"/>
+            <a:ext cx="1172261" cy="292608"/>
+          </a:xfrm>
+          <a:prstGeom prst="rect">
+            <a:avLst/>
+          </a:prstGeom>
+          <a:noFill/>
+          <a:ln/>
+        </p:spPr>
+        <p:txBody>
+          <a:bodyPr wrap="square" lIns="0" tIns="0" rIns="0" bIns="0" rtlCol="0" anchor="ctr"/>
+          <a:lstStyle/>
+          <a:p>
+            <a:pPr algn="ctr" indent="0" marL="0">
+              <a:buNone/>
+            </a:pPr>
+            <a:r>
+              <a:rPr lang="en-US" sz="950" spc="150" kern="0" dirty="0">
+                <a:solidFill>
+                  <a:srgbClr val="D4D4D4"/>
+                </a:solidFill>
+                <a:latin typeface="Segoe UI Semibold" pitchFamily="34" charset="0"/>
+                <a:ea typeface="Segoe UI Semibold" pitchFamily="34" charset="-122"/>
+                <a:cs typeface="Segoe UI Semibold" pitchFamily="34" charset="-120"/>
+              </a:rPr>
+              <a:t>KETUA TIM</a:t>
+            </a:r>
+            <a:endParaRPr lang="en-US" sz="950" dirty="0"/>
+          </a:p>
+        </p:txBody>
+      </p:sp>
+      <p:sp>
+        <p:nvSpPr>
+          <p:cNvPr id="15" name="Text 13"/>
           <p:cNvSpPr txBox="1"/>
           <p:nvPr/>
         </p:nvSpPr>
         <p:spPr>
           <a:xfrm>
             <a:off x="3072384" y="2697480"/>
-            <a:ext cx="1645920" cy="274320"/>
-          </a:xfrm>
-          <a:prstGeom prst="rect">
-            <a:avLst/>
-          </a:prstGeom>
-          <a:noFill/>
-          <a:ln/>
-        </p:spPr>
-        <p:txBody>
-          <a:bodyPr wrap="square" lIns="0" tIns="0" rIns="0" bIns="0" rtlCol="0" anchor="t"/>
-          <a:lstStyle/>
-          <a:p>
-            <a:pPr indent="0" marL="0">
-              <a:buNone/>
-            </a:pPr>
-            <a:r>
-              <a:rPr lang="en-US" sz="1150" dirty="0">
-                <a:solidFill>
-                  <a:srgbClr val="5C5C5C"/>
+            <a:ext cx="1691640" cy="621792"/>
+          </a:xfrm>
+          <a:prstGeom prst="rect">
+            <a:avLst/>
+          </a:prstGeom>
+          <a:noFill/>
+          <a:ln/>
+        </p:spPr>
+        <p:txBody>
+          <a:bodyPr wrap="square" lIns="0" tIns="0" rIns="0" bIns="0" rtlCol="0" anchor="b"/>
+          <a:lstStyle/>
+          <a:p>
+            <a:pPr indent="0" marL="0">
+              <a:buNone/>
+            </a:pPr>
+            <a:r>
+              <a:rPr lang="en-US" sz="1500" dirty="0">
+                <a:solidFill>
+                  <a:srgbClr val="FFFFFF"/>
+                </a:solidFill>
+                <a:latin typeface="Segoe UI Semibold" pitchFamily="34" charset="0"/>
+                <a:ea typeface="Segoe UI Semibold" pitchFamily="34" charset="-122"/>
+                <a:cs typeface="Segoe UI Semibold" pitchFamily="34" charset="-120"/>
+              </a:rPr>
+              <a:t>Azrian Dalimunthe</a:t>
+            </a:r>
+            <a:endParaRPr lang="en-US" sz="1500" dirty="0"/>
+          </a:p>
+        </p:txBody>
+      </p:sp>
+      <p:sp>
+        <p:nvSpPr>
+          <p:cNvPr id="16" name="Text 14"/>
+          <p:cNvSpPr txBox="1"/>
+          <p:nvPr/>
+        </p:nvSpPr>
+        <p:spPr>
+          <a:xfrm>
+            <a:off x="3072384" y="3383280"/>
+            <a:ext cx="1691640" cy="274320"/>
+          </a:xfrm>
+          <a:prstGeom prst="rect">
+            <a:avLst/>
+          </a:prstGeom>
+          <a:noFill/>
+          <a:ln/>
+        </p:spPr>
+        <p:txBody>
+          <a:bodyPr wrap="square" lIns="0" tIns="0" rIns="0" bIns="0" rtlCol="0" anchor="t"/>
+          <a:lstStyle/>
+          <a:p>
+            <a:pPr indent="0" marL="0">
+              <a:buNone/>
+            </a:pPr>
+            <a:r>
+              <a:rPr lang="en-US" sz="1200" dirty="0">
+                <a:solidFill>
+                  <a:srgbClr val="D4D4D4"/>
                 </a:solidFill>
                 <a:latin typeface="Segoe UI" pitchFamily="34" charset="0"/>
                 <a:ea typeface="Segoe UI" pitchFamily="34" charset="-122"/>
                 <a:cs typeface="Segoe UI" pitchFamily="34" charset="-120"/>
               </a:rPr>
-              <a:t>Anggota 2</a:t>
-            </a:r>
-            <a:endParaRPr lang="en-US" sz="1150" dirty="0"/>
-          </a:p>
-        </p:txBody>
-      </p:sp>
-      <p:sp>
-        <p:nvSpPr>
-          <p:cNvPr id="13" name="Text 11"/>
-          <p:cNvSpPr txBox="1"/>
-          <p:nvPr/>
-        </p:nvSpPr>
-        <p:spPr>
-          <a:xfrm>
-            <a:off x="3072384" y="2971800"/>
-            <a:ext cx="1691640" cy="640080"/>
-          </a:xfrm>
-          <a:prstGeom prst="rect">
-            <a:avLst/>
-          </a:prstGeom>
-          <a:noFill/>
-          <a:ln/>
-        </p:spPr>
-        <p:txBody>
-          <a:bodyPr wrap="square" lIns="0" tIns="0" rIns="0" bIns="0" rtlCol="0" anchor="t"/>
-          <a:lstStyle/>
-          <a:p>
-            <a:pPr indent="0" marL="0">
-              <a:buNone/>
-            </a:pPr>
-            <a:r>
-              <a:rPr lang="en-US" sz="1500" dirty="0">
-                <a:solidFill>
-                  <a:srgbClr val="0A0A0A"/>
-                </a:solidFill>
-                <a:latin typeface="Segoe UI Semibold" pitchFamily="34" charset="0"/>
-                <a:ea typeface="Segoe UI Semibold" pitchFamily="34" charset="-122"/>
-                <a:cs typeface="Segoe UI Semibold" pitchFamily="34" charset="-120"/>
-              </a:rPr>
               <a:t>Frontend katalog</a:t>
             </a:r>
-            <a:endParaRPr lang="en-US" sz="1500" dirty="0"/>
-          </a:p>
-        </p:txBody>
-      </p:sp>
-      <p:sp>
-        <p:nvSpPr>
-          <p:cNvPr id="14" name="Text 12"/>
-          <p:cNvSpPr txBox="1"/>
-          <p:nvPr/>
-        </p:nvSpPr>
-        <p:spPr>
-          <a:xfrm>
-            <a:off x="3072384" y="3749040"/>
-            <a:ext cx="1691640" cy="2011680"/>
+            <a:endParaRPr lang="en-US" sz="1200" dirty="0"/>
+          </a:p>
+        </p:txBody>
+      </p:sp>
+      <p:sp>
+        <p:nvSpPr>
+          <p:cNvPr id="17" name="Shape 15"/>
+          <p:cNvSpPr/>
+          <p:nvPr/>
+        </p:nvSpPr>
+        <p:spPr>
+          <a:xfrm>
+            <a:off x="3072384" y="3794760"/>
+            <a:ext cx="1591056" cy="0"/>
+          </a:xfrm>
+          <a:prstGeom prst="line">
+            <a:avLst/>
+          </a:prstGeom>
+          <a:noFill/>
+          <a:ln w="12700">
+            <a:solidFill>
+              <a:srgbClr val="262626"/>
+            </a:solidFill>
+            <a:prstDash val="solid"/>
+          </a:ln>
+        </p:spPr>
+      </p:sp>
+      <p:sp>
+        <p:nvSpPr>
+          <p:cNvPr id="18" name="Text 16"/>
+          <p:cNvSpPr txBox="1"/>
+          <p:nvPr/>
+        </p:nvSpPr>
+        <p:spPr>
+          <a:xfrm>
+            <a:off x="3072384" y="3977640"/>
+            <a:ext cx="1691640" cy="1828800"/>
           </a:xfrm>
           <a:prstGeom prst="rect">
             <a:avLst/>
@@ -9742,7 +9849,7 @@
             <a:r>
               <a:rPr lang="en-US" sz="1150" dirty="0">
                 <a:solidFill>
-                  <a:srgbClr val="5C5C5C"/>
+                  <a:srgbClr val="A3A3A3"/>
                 </a:solidFill>
                 <a:latin typeface="Segoe UI" pitchFamily="34" charset="0"/>
                 <a:ea typeface="Segoe UI" pitchFamily="34" charset="-122"/>
@@ -9763,7 +9870,7 @@
             <a:r>
               <a:rPr lang="en-US" sz="1150" dirty="0">
                 <a:solidFill>
-                  <a:srgbClr val="5C5C5C"/>
+                  <a:srgbClr val="A3A3A3"/>
                 </a:solidFill>
                 <a:latin typeface="Segoe UI" pitchFamily="34" charset="0"/>
                 <a:ea typeface="Segoe UI" pitchFamily="34" charset="-122"/>
@@ -9784,7 +9891,7 @@
             <a:r>
               <a:rPr lang="en-US" sz="1150" dirty="0">
                 <a:solidFill>
-                  <a:srgbClr val="5C5C5C"/>
+                  <a:srgbClr val="A3A3A3"/>
                 </a:solidFill>
                 <a:latin typeface="Segoe UI" pitchFamily="34" charset="0"/>
                 <a:ea typeface="Segoe UI" pitchFamily="34" charset="-122"/>
@@ -9798,7 +9905,7 @@
       </p:sp>
       <p:sp>
         <p:nvSpPr>
-          <p:cNvPr id="15" name="Shape 13"/>
+          <p:cNvPr id="19" name="Shape 17"/>
           <p:cNvSpPr/>
           <p:nvPr/>
         </p:nvSpPr>
@@ -9820,7 +9927,7 @@
       </p:sp>
       <p:sp>
         <p:nvSpPr>
-          <p:cNvPr id="16" name="Text 14"/>
+          <p:cNvPr id="20" name="Text 18"/>
           <p:cNvSpPr txBox="1"/>
           <p:nvPr/>
         </p:nvSpPr>
@@ -9859,92 +9966,115 @@
       </p:sp>
       <p:sp>
         <p:nvSpPr>
-          <p:cNvPr id="17" name="Text 15"/>
+          <p:cNvPr id="21" name="Text 19"/>
           <p:cNvSpPr txBox="1"/>
           <p:nvPr/>
         </p:nvSpPr>
         <p:spPr>
           <a:xfrm>
             <a:off x="5340096" y="2697480"/>
-            <a:ext cx="1645920" cy="274320"/>
-          </a:xfrm>
-          <a:prstGeom prst="rect">
-            <a:avLst/>
-          </a:prstGeom>
-          <a:noFill/>
-          <a:ln/>
-        </p:spPr>
-        <p:txBody>
-          <a:bodyPr wrap="square" lIns="0" tIns="0" rIns="0" bIns="0" rtlCol="0" anchor="t"/>
-          <a:lstStyle/>
-          <a:p>
-            <a:pPr indent="0" marL="0">
-              <a:buNone/>
-            </a:pPr>
-            <a:r>
-              <a:rPr lang="en-US" sz="1150" dirty="0">
-                <a:solidFill>
-                  <a:srgbClr val="5C5C5C"/>
+            <a:ext cx="1691640" cy="621792"/>
+          </a:xfrm>
+          <a:prstGeom prst="rect">
+            <a:avLst/>
+          </a:prstGeom>
+          <a:noFill/>
+          <a:ln/>
+        </p:spPr>
+        <p:txBody>
+          <a:bodyPr wrap="square" lIns="0" tIns="0" rIns="0" bIns="0" rtlCol="0" anchor="b"/>
+          <a:lstStyle/>
+          <a:p>
+            <a:pPr indent="0" marL="0">
+              <a:buNone/>
+            </a:pPr>
+            <a:r>
+              <a:rPr lang="en-US" sz="1500" dirty="0">
+                <a:solidFill>
+                  <a:srgbClr val="0A0A0A"/>
+                </a:solidFill>
+                <a:latin typeface="Segoe UI Semibold" pitchFamily="34" charset="0"/>
+                <a:ea typeface="Segoe UI Semibold" pitchFamily="34" charset="-122"/>
+                <a:cs typeface="Segoe UI Semibold" pitchFamily="34" charset="-120"/>
+              </a:rPr>
+              <a:t>Rizki Kusnadi</a:t>
+            </a:r>
+            <a:endParaRPr lang="en-US" sz="1500" dirty="0"/>
+          </a:p>
+        </p:txBody>
+      </p:sp>
+      <p:sp>
+        <p:nvSpPr>
+          <p:cNvPr id="22" name="Text 20"/>
+          <p:cNvSpPr txBox="1"/>
+          <p:nvPr/>
+        </p:nvSpPr>
+        <p:spPr>
+          <a:xfrm>
+            <a:off x="5340096" y="3383280"/>
+            <a:ext cx="1691640" cy="274320"/>
+          </a:xfrm>
+          <a:prstGeom prst="rect">
+            <a:avLst/>
+          </a:prstGeom>
+          <a:noFill/>
+          <a:ln/>
+        </p:spPr>
+        <p:txBody>
+          <a:bodyPr wrap="square" lIns="0" tIns="0" rIns="0" bIns="0" rtlCol="0" anchor="t"/>
+          <a:lstStyle/>
+          <a:p>
+            <a:pPr indent="0" marL="0">
+              <a:buNone/>
+            </a:pPr>
+            <a:r>
+              <a:rPr lang="en-US" sz="1200" dirty="0">
+                <a:solidFill>
+                  <a:srgbClr val="0A0A0A"/>
                 </a:solidFill>
                 <a:latin typeface="Segoe UI" pitchFamily="34" charset="0"/>
                 <a:ea typeface="Segoe UI" pitchFamily="34" charset="-122"/>
                 <a:cs typeface="Segoe UI" pitchFamily="34" charset="-120"/>
               </a:rPr>
-              <a:t>Anggota 3</a:t>
-            </a:r>
-            <a:endParaRPr lang="en-US" sz="1150" dirty="0"/>
-          </a:p>
-        </p:txBody>
-      </p:sp>
-      <p:sp>
-        <p:nvSpPr>
-          <p:cNvPr id="18" name="Text 16"/>
-          <p:cNvSpPr txBox="1"/>
-          <p:nvPr/>
-        </p:nvSpPr>
-        <p:spPr>
-          <a:xfrm>
-            <a:off x="5340096" y="2971800"/>
-            <a:ext cx="1691640" cy="640080"/>
-          </a:xfrm>
-          <a:prstGeom prst="rect">
-            <a:avLst/>
-          </a:prstGeom>
-          <a:noFill/>
-          <a:ln/>
-        </p:spPr>
-        <p:txBody>
-          <a:bodyPr wrap="square" lIns="0" tIns="0" rIns="0" bIns="0" rtlCol="0" anchor="t"/>
-          <a:lstStyle/>
-          <a:p>
-            <a:pPr indent="0" marL="0">
-              <a:buNone/>
-            </a:pPr>
-            <a:r>
-              <a:rPr lang="en-US" sz="1500" dirty="0">
-                <a:solidFill>
-                  <a:srgbClr val="0A0A0A"/>
-                </a:solidFill>
-                <a:latin typeface="Segoe UI Semibold" pitchFamily="34" charset="0"/>
-                <a:ea typeface="Segoe UI Semibold" pitchFamily="34" charset="-122"/>
-                <a:cs typeface="Segoe UI Semibold" pitchFamily="34" charset="-120"/>
-              </a:rPr>
               <a:t>Frontend transaksi</a:t>
             </a:r>
-            <a:endParaRPr lang="en-US" sz="1500" dirty="0"/>
-          </a:p>
-        </p:txBody>
-      </p:sp>
-      <p:sp>
-        <p:nvSpPr>
-          <p:cNvPr id="19" name="Text 17"/>
-          <p:cNvSpPr txBox="1"/>
-          <p:nvPr/>
-        </p:nvSpPr>
-        <p:spPr>
-          <a:xfrm>
-            <a:off x="5340096" y="3749040"/>
-            <a:ext cx="1691640" cy="2011680"/>
+            <a:endParaRPr lang="en-US" sz="1200" dirty="0"/>
+          </a:p>
+        </p:txBody>
+      </p:sp>
+      <p:sp>
+        <p:nvSpPr>
+          <p:cNvPr id="23" name="Shape 21"/>
+          <p:cNvSpPr/>
+          <p:nvPr/>
+        </p:nvSpPr>
+        <p:spPr>
+          <a:xfrm>
+            <a:off x="5340096" y="3794760"/>
+            <a:ext cx="1591056" cy="0"/>
+          </a:xfrm>
+          <a:prstGeom prst="line">
+            <a:avLst/>
+          </a:prstGeom>
+          <a:noFill/>
+          <a:ln w="12700">
+            <a:solidFill>
+              <a:srgbClr val="E6E6E6"/>
+            </a:solidFill>
+            <a:prstDash val="solid"/>
+          </a:ln>
+        </p:spPr>
+      </p:sp>
+      <p:sp>
+        <p:nvSpPr>
+          <p:cNvPr id="24" name="Text 22"/>
+          <p:cNvSpPr txBox="1"/>
+          <p:nvPr/>
+        </p:nvSpPr>
+        <p:spPr>
+          <a:xfrm>
+            <a:off x="5340096" y="3977640"/>
+            <a:ext cx="1691640" cy="1828800"/>
           </a:xfrm>
           <a:prstGeom prst="rect">
             <a:avLst/>
@@ -10022,7 +10152,7 @@
       </p:sp>
       <p:sp>
         <p:nvSpPr>
-          <p:cNvPr id="20" name="Shape 18"/>
+          <p:cNvPr id="25" name="Shape 23"/>
           <p:cNvSpPr/>
           <p:nvPr/>
         </p:nvSpPr>
@@ -10044,7 +10174,7 @@
       </p:sp>
       <p:sp>
         <p:nvSpPr>
-          <p:cNvPr id="21" name="Text 19"/>
+          <p:cNvPr id="26" name="Text 24"/>
           <p:cNvSpPr txBox="1"/>
           <p:nvPr/>
         </p:nvSpPr>
@@ -10083,92 +10213,115 @@
       </p:sp>
       <p:sp>
         <p:nvSpPr>
-          <p:cNvPr id="22" name="Text 20"/>
+          <p:cNvPr id="27" name="Text 25"/>
           <p:cNvSpPr txBox="1"/>
           <p:nvPr/>
         </p:nvSpPr>
         <p:spPr>
           <a:xfrm>
             <a:off x="7607808" y="2697480"/>
-            <a:ext cx="1645920" cy="274320"/>
-          </a:xfrm>
-          <a:prstGeom prst="rect">
-            <a:avLst/>
-          </a:prstGeom>
-          <a:noFill/>
-          <a:ln/>
-        </p:spPr>
-        <p:txBody>
-          <a:bodyPr wrap="square" lIns="0" tIns="0" rIns="0" bIns="0" rtlCol="0" anchor="t"/>
-          <a:lstStyle/>
-          <a:p>
-            <a:pPr indent="0" marL="0">
-              <a:buNone/>
-            </a:pPr>
-            <a:r>
-              <a:rPr lang="en-US" sz="1150" dirty="0">
-                <a:solidFill>
-                  <a:srgbClr val="5C5C5C"/>
+            <a:ext cx="1691640" cy="621792"/>
+          </a:xfrm>
+          <a:prstGeom prst="rect">
+            <a:avLst/>
+          </a:prstGeom>
+          <a:noFill/>
+          <a:ln/>
+        </p:spPr>
+        <p:txBody>
+          <a:bodyPr wrap="square" lIns="0" tIns="0" rIns="0" bIns="0" rtlCol="0" anchor="b"/>
+          <a:lstStyle/>
+          <a:p>
+            <a:pPr indent="0" marL="0">
+              <a:buNone/>
+            </a:pPr>
+            <a:r>
+              <a:rPr lang="en-US" sz="1500" dirty="0">
+                <a:solidFill>
+                  <a:srgbClr val="0A0A0A"/>
+                </a:solidFill>
+                <a:latin typeface="Segoe UI Semibold" pitchFamily="34" charset="0"/>
+                <a:ea typeface="Segoe UI Semibold" pitchFamily="34" charset="-122"/>
+                <a:cs typeface="Segoe UI Semibold" pitchFamily="34" charset="-120"/>
+              </a:rPr>
+              <a:t>Doni Anggara</a:t>
+            </a:r>
+            <a:endParaRPr lang="en-US" sz="1500" dirty="0"/>
+          </a:p>
+        </p:txBody>
+      </p:sp>
+      <p:sp>
+        <p:nvSpPr>
+          <p:cNvPr id="28" name="Text 26"/>
+          <p:cNvSpPr txBox="1"/>
+          <p:nvPr/>
+        </p:nvSpPr>
+        <p:spPr>
+          <a:xfrm>
+            <a:off x="7607808" y="3383280"/>
+            <a:ext cx="1691640" cy="274320"/>
+          </a:xfrm>
+          <a:prstGeom prst="rect">
+            <a:avLst/>
+          </a:prstGeom>
+          <a:noFill/>
+          <a:ln/>
+        </p:spPr>
+        <p:txBody>
+          <a:bodyPr wrap="square" lIns="0" tIns="0" rIns="0" bIns="0" rtlCol="0" anchor="t"/>
+          <a:lstStyle/>
+          <a:p>
+            <a:pPr indent="0" marL="0">
+              <a:buNone/>
+            </a:pPr>
+            <a:r>
+              <a:rPr lang="en-US" sz="1200" dirty="0">
+                <a:solidFill>
+                  <a:srgbClr val="0A0A0A"/>
                 </a:solidFill>
                 <a:latin typeface="Segoe UI" pitchFamily="34" charset="0"/>
                 <a:ea typeface="Segoe UI" pitchFamily="34" charset="-122"/>
                 <a:cs typeface="Segoe UI" pitchFamily="34" charset="-120"/>
               </a:rPr>
-              <a:t>Anggota 4</a:t>
-            </a:r>
-            <a:endParaRPr lang="en-US" sz="1150" dirty="0"/>
-          </a:p>
-        </p:txBody>
-      </p:sp>
-      <p:sp>
-        <p:nvSpPr>
-          <p:cNvPr id="23" name="Text 21"/>
-          <p:cNvSpPr txBox="1"/>
-          <p:nvPr/>
-        </p:nvSpPr>
-        <p:spPr>
-          <a:xfrm>
-            <a:off x="7607808" y="2971800"/>
-            <a:ext cx="1691640" cy="640080"/>
-          </a:xfrm>
-          <a:prstGeom prst="rect">
-            <a:avLst/>
-          </a:prstGeom>
-          <a:noFill/>
-          <a:ln/>
-        </p:spPr>
-        <p:txBody>
-          <a:bodyPr wrap="square" lIns="0" tIns="0" rIns="0" bIns="0" rtlCol="0" anchor="t"/>
-          <a:lstStyle/>
-          <a:p>
-            <a:pPr indent="0" marL="0">
-              <a:buNone/>
-            </a:pPr>
-            <a:r>
-              <a:rPr lang="en-US" sz="1500" dirty="0">
-                <a:solidFill>
-                  <a:srgbClr val="0A0A0A"/>
-                </a:solidFill>
-                <a:latin typeface="Segoe UI Semibold" pitchFamily="34" charset="0"/>
-                <a:ea typeface="Segoe UI Semibold" pitchFamily="34" charset="-122"/>
-                <a:cs typeface="Segoe UI Semibold" pitchFamily="34" charset="-120"/>
-              </a:rPr>
               <a:t>Backend pesanan</a:t>
             </a:r>
-            <a:endParaRPr lang="en-US" sz="1500" dirty="0"/>
-          </a:p>
-        </p:txBody>
-      </p:sp>
-      <p:sp>
-        <p:nvSpPr>
-          <p:cNvPr id="24" name="Text 22"/>
-          <p:cNvSpPr txBox="1"/>
-          <p:nvPr/>
-        </p:nvSpPr>
-        <p:spPr>
-          <a:xfrm>
-            <a:off x="7607808" y="3749040"/>
-            <a:ext cx="1691640" cy="2011680"/>
+            <a:endParaRPr lang="en-US" sz="1200" dirty="0"/>
+          </a:p>
+        </p:txBody>
+      </p:sp>
+      <p:sp>
+        <p:nvSpPr>
+          <p:cNvPr id="29" name="Shape 27"/>
+          <p:cNvSpPr/>
+          <p:nvPr/>
+        </p:nvSpPr>
+        <p:spPr>
+          <a:xfrm>
+            <a:off x="7607808" y="3794760"/>
+            <a:ext cx="1591056" cy="0"/>
+          </a:xfrm>
+          <a:prstGeom prst="line">
+            <a:avLst/>
+          </a:prstGeom>
+          <a:noFill/>
+          <a:ln w="12700">
+            <a:solidFill>
+              <a:srgbClr val="E6E6E6"/>
+            </a:solidFill>
+            <a:prstDash val="solid"/>
+          </a:ln>
+        </p:spPr>
+      </p:sp>
+      <p:sp>
+        <p:nvSpPr>
+          <p:cNvPr id="30" name="Text 28"/>
+          <p:cNvSpPr txBox="1"/>
+          <p:nvPr/>
+        </p:nvSpPr>
+        <p:spPr>
+          <a:xfrm>
+            <a:off x="7607808" y="3977640"/>
+            <a:ext cx="1691640" cy="1828800"/>
           </a:xfrm>
           <a:prstGeom prst="rect">
             <a:avLst/>
@@ -10246,7 +10399,7 @@
       </p:sp>
       <p:sp>
         <p:nvSpPr>
-          <p:cNvPr id="25" name="Shape 23"/>
+          <p:cNvPr id="31" name="Shape 29"/>
           <p:cNvSpPr/>
           <p:nvPr/>
         </p:nvSpPr>
@@ -10268,7 +10421,7 @@
       </p:sp>
       <p:sp>
         <p:nvSpPr>
-          <p:cNvPr id="26" name="Text 24"/>
+          <p:cNvPr id="32" name="Text 30"/>
           <p:cNvSpPr txBox="1"/>
           <p:nvPr/>
         </p:nvSpPr>
@@ -10307,92 +10460,115 @@
       </p:sp>
       <p:sp>
         <p:nvSpPr>
-          <p:cNvPr id="27" name="Text 25"/>
+          <p:cNvPr id="33" name="Text 31"/>
           <p:cNvSpPr txBox="1"/>
           <p:nvPr/>
         </p:nvSpPr>
         <p:spPr>
           <a:xfrm>
             <a:off x="9875520" y="2697480"/>
-            <a:ext cx="1645920" cy="274320"/>
-          </a:xfrm>
-          <a:prstGeom prst="rect">
-            <a:avLst/>
-          </a:prstGeom>
-          <a:noFill/>
-          <a:ln/>
-        </p:spPr>
-        <p:txBody>
-          <a:bodyPr wrap="square" lIns="0" tIns="0" rIns="0" bIns="0" rtlCol="0" anchor="t"/>
-          <a:lstStyle/>
-          <a:p>
-            <a:pPr indent="0" marL="0">
-              <a:buNone/>
-            </a:pPr>
-            <a:r>
-              <a:rPr lang="en-US" sz="1150" dirty="0">
-                <a:solidFill>
-                  <a:srgbClr val="5C5C5C"/>
+            <a:ext cx="1691640" cy="621792"/>
+          </a:xfrm>
+          <a:prstGeom prst="rect">
+            <a:avLst/>
+          </a:prstGeom>
+          <a:noFill/>
+          <a:ln/>
+        </p:spPr>
+        <p:txBody>
+          <a:bodyPr wrap="square" lIns="0" tIns="0" rIns="0" bIns="0" rtlCol="0" anchor="b"/>
+          <a:lstStyle/>
+          <a:p>
+            <a:pPr indent="0" marL="0">
+              <a:buNone/>
+            </a:pPr>
+            <a:r>
+              <a:rPr lang="en-US" sz="1500" dirty="0">
+                <a:solidFill>
+                  <a:srgbClr val="0A0A0A"/>
+                </a:solidFill>
+                <a:latin typeface="Segoe UI Semibold" pitchFamily="34" charset="0"/>
+                <a:ea typeface="Segoe UI Semibold" pitchFamily="34" charset="-122"/>
+                <a:cs typeface="Segoe UI Semibold" pitchFamily="34" charset="-120"/>
+              </a:rPr>
+              <a:t>Zulfikar Satya Nugraha</a:t>
+            </a:r>
+            <a:endParaRPr lang="en-US" sz="1500" dirty="0"/>
+          </a:p>
+        </p:txBody>
+      </p:sp>
+      <p:sp>
+        <p:nvSpPr>
+          <p:cNvPr id="34" name="Text 32"/>
+          <p:cNvSpPr txBox="1"/>
+          <p:nvPr/>
+        </p:nvSpPr>
+        <p:spPr>
+          <a:xfrm>
+            <a:off x="9875520" y="3383280"/>
+            <a:ext cx="1691640" cy="274320"/>
+          </a:xfrm>
+          <a:prstGeom prst="rect">
+            <a:avLst/>
+          </a:prstGeom>
+          <a:noFill/>
+          <a:ln/>
+        </p:spPr>
+        <p:txBody>
+          <a:bodyPr wrap="square" lIns="0" tIns="0" rIns="0" bIns="0" rtlCol="0" anchor="t"/>
+          <a:lstStyle/>
+          <a:p>
+            <a:pPr indent="0" marL="0">
+              <a:buNone/>
+            </a:pPr>
+            <a:r>
+              <a:rPr lang="en-US" sz="1200" dirty="0">
+                <a:solidFill>
+                  <a:srgbClr val="0A0A0A"/>
                 </a:solidFill>
                 <a:latin typeface="Segoe UI" pitchFamily="34" charset="0"/>
                 <a:ea typeface="Segoe UI" pitchFamily="34" charset="-122"/>
                 <a:cs typeface="Segoe UI" pitchFamily="34" charset="-120"/>
               </a:rPr>
-              <a:t>Anggota 5</a:t>
-            </a:r>
-            <a:endParaRPr lang="en-US" sz="1150" dirty="0"/>
-          </a:p>
-        </p:txBody>
-      </p:sp>
-      <p:sp>
-        <p:nvSpPr>
-          <p:cNvPr id="28" name="Text 26"/>
-          <p:cNvSpPr txBox="1"/>
-          <p:nvPr/>
-        </p:nvSpPr>
-        <p:spPr>
-          <a:xfrm>
-            <a:off x="9875520" y="2971800"/>
-            <a:ext cx="1691640" cy="640080"/>
-          </a:xfrm>
-          <a:prstGeom prst="rect">
-            <a:avLst/>
-          </a:prstGeom>
-          <a:noFill/>
-          <a:ln/>
-        </p:spPr>
-        <p:txBody>
-          <a:bodyPr wrap="square" lIns="0" tIns="0" rIns="0" bIns="0" rtlCol="0" anchor="t"/>
-          <a:lstStyle/>
-          <a:p>
-            <a:pPr indent="0" marL="0">
-              <a:buNone/>
-            </a:pPr>
-            <a:r>
-              <a:rPr lang="en-US" sz="1500" dirty="0">
-                <a:solidFill>
-                  <a:srgbClr val="0A0A0A"/>
-                </a:solidFill>
-                <a:latin typeface="Segoe UI Semibold" pitchFamily="34" charset="0"/>
-                <a:ea typeface="Segoe UI Semibold" pitchFamily="34" charset="-122"/>
-                <a:cs typeface="Segoe UI Semibold" pitchFamily="34" charset="-120"/>
-              </a:rPr>
               <a:t>Admin panel &amp; QA</a:t>
             </a:r>
-            <a:endParaRPr lang="en-US" sz="1500" dirty="0"/>
-          </a:p>
-        </p:txBody>
-      </p:sp>
-      <p:sp>
-        <p:nvSpPr>
-          <p:cNvPr id="29" name="Text 27"/>
-          <p:cNvSpPr txBox="1"/>
-          <p:nvPr/>
-        </p:nvSpPr>
-        <p:spPr>
-          <a:xfrm>
-            <a:off x="9875520" y="3749040"/>
-            <a:ext cx="1691640" cy="2011680"/>
+            <a:endParaRPr lang="en-US" sz="1200" dirty="0"/>
+          </a:p>
+        </p:txBody>
+      </p:sp>
+      <p:sp>
+        <p:nvSpPr>
+          <p:cNvPr id="35" name="Shape 33"/>
+          <p:cNvSpPr/>
+          <p:nvPr/>
+        </p:nvSpPr>
+        <p:spPr>
+          <a:xfrm>
+            <a:off x="9875520" y="3794760"/>
+            <a:ext cx="1591056" cy="0"/>
+          </a:xfrm>
+          <a:prstGeom prst="line">
+            <a:avLst/>
+          </a:prstGeom>
+          <a:noFill/>
+          <a:ln w="12700">
+            <a:solidFill>
+              <a:srgbClr val="E6E6E6"/>
+            </a:solidFill>
+            <a:prstDash val="solid"/>
+          </a:ln>
+        </p:spPr>
+      </p:sp>
+      <p:sp>
+        <p:nvSpPr>
+          <p:cNvPr id="36" name="Text 34"/>
+          <p:cNvSpPr txBox="1"/>
+          <p:nvPr/>
+        </p:nvSpPr>
+        <p:spPr>
+          <a:xfrm>
+            <a:off x="9875520" y="3977640"/>
+            <a:ext cx="1691640" cy="1828800"/>
           </a:xfrm>
           <a:prstGeom prst="rect">
             <a:avLst/>

</xml_diff>

<commit_message>
docs: PPT slide anggota memakai foto profil GitHub
Pemilik meminta foto anggota sama dengan foto profil GitHub masing-masing.
ambil-foto.cjs mengunduh avatar publik lalu memotongnya bulat; avatar
transparan diberi latar putih dan semua foto diberi garis tepi agar ikon
bawaan GitHub (dua anggota belum memasang foto) tetap terlihat di kartu abu.

Co-Authored-By: Claude <noreply@anthropic.com>
</commit_message>
<xml_diff>
--- a/docs/Presentasi_ECommerce_TokoKita.pptx
+++ b/docs/Presentasi_ECommerce_TokoKita.pptx
@@ -131,21 +131,21 @@
   <p:extLst>
     <p:ext uri="{521415D9-36F7-43E2-AB2F-B90AF26B5E84}">
       <p14:sectionLst xmlns:p14="http://schemas.microsoft.com/office/powerpoint/2010/main">
-        <p14:section name="Pembuka" id="{92135303-6b5a-34d0-3ed5-b8363e998e07}">
+        <p14:section name="Pembuka" id="{76f61e40-1215-abdf-4e2b-43a2087cf575}">
           <p14:sldIdLst>
             <p14:sldId id="256"/>
             <p14:sldId id="257"/>
             <p14:sldId id="258"/>
           </p14:sldIdLst>
         </p14:section>
-        <p14:section name="Latar &amp; cakupan" id="{909c61dc-6ebe-1321-384b-baec62261ca4}">
+        <p14:section name="Latar &amp; cakupan" id="{5e0d4aa8-2005-7aea-464d-664dc16751bb}">
           <p14:sldIdLst>
             <p14:sldId id="259"/>
             <p14:sldId id="260"/>
             <p14:sldId id="261"/>
           </p14:sldIdLst>
         </p14:section>
-        <p14:section name="Teknologi" id="{bc0e320a-fccf-a88d-3c9d-8a84b3a428c8}">
+        <p14:section name="Teknologi" id="{d41a3be1-973e-df31-f279-f82c47091f10}">
           <p14:sldIdLst>
             <p14:sldId id="262"/>
             <p14:sldId id="263"/>
@@ -154,7 +154,7 @@
             <p14:sldId id="266"/>
           </p14:sldIdLst>
         </p14:section>
-        <p14:section name="Tampilan aplikasi" id="{e2f1ee70-ee21-7dec-b986-e8beb039cb79}">
+        <p14:section name="Tampilan aplikasi" id="{0067de09-c7dd-76aa-5fd7-a6afdca7bb38}">
           <p14:sldIdLst>
             <p14:sldId id="267"/>
             <p14:sldId id="268"/>
@@ -164,13 +164,13 @@
             <p14:sldId id="272"/>
           </p14:sldIdLst>
         </p14:section>
-        <p14:section name="Tim &amp; cara kerja" id="{3e8bc6ef-924c-3e3a-76ec-7e7d9d3f3a76}">
+        <p14:section name="Tim &amp; cara kerja" id="{829c44b4-74d9-bc26-e54b-14d123487a35}">
           <p14:sldIdLst>
             <p14:sldId id="273"/>
             <p14:sldId id="274"/>
           </p14:sldIdLst>
         </p14:section>
-        <p14:section name="Kualitas &amp; demo" id="{77b90256-f051-87a1-5ba1-017717fa0579}">
+        <p14:section name="Kualitas &amp; demo" id="{b4f2d86c-c16d-7502-dbf9-5802f1e1d7a4}">
           <p14:sldIdLst>
             <p14:sldId id="275"/>
             <p14:sldId id="276"/>
@@ -179,7 +179,7 @@
             <p14:sldId id="279"/>
           </p14:sldIdLst>
         </p14:section>
-        <p14:section name="Penutup" id="{c71a2fb5-57ec-3901-c68f-e10d370f69ac}">
+        <p14:section name="Penutup" id="{2d3a8fbb-e102-4f8a-b6a8-a6e6f1837ffb}">
           <p14:sldIdLst>
             <p14:sldId id="280"/>
           </p14:sldIdLst>
@@ -12756,98 +12756,90 @@
           <a:ln/>
         </p:spPr>
       </p:sp>
-      <p:sp>
-        <p:nvSpPr>
-          <p:cNvPr id="6" name="Shape 4"/>
+      <p:pic>
+        <p:nvPicPr>
+          <p:cNvPr id="6" name="Image 0" descr="Foto profil Azrian Dalimunthe">    </p:cNvPr>
+          <p:cNvPicPr>
+            <a:picLocks noChangeAspect="1"/>
+          </p:cNvPicPr>
+          <p:nvPr/>
+        </p:nvPicPr>
+        <p:blipFill>
+          <a:blip r:embed="rId1"/>
+          <a:stretch>
+            <a:fillRect/>
+          </a:stretch>
+        </p:blipFill>
+        <p:spPr>
+          <a:xfrm>
+            <a:off x="1005840" y="2514600"/>
+            <a:ext cx="1188720" cy="1188720"/>
+          </a:xfrm>
+          <a:prstGeom prst="rect">
+            <a:avLst/>
+          </a:prstGeom>
+        </p:spPr>
+      </p:pic>
+      <p:sp>
+        <p:nvSpPr>
+          <p:cNvPr id="7" name="Shape 4"/>
           <p:cNvSpPr/>
           <p:nvPr/>
         </p:nvSpPr>
         <p:spPr>
           <a:xfrm>
-            <a:off x="1097280" y="2788920"/>
-            <a:ext cx="1005840" cy="1005840"/>
+            <a:off x="1005840" y="2514600"/>
+            <a:ext cx="1188720" cy="1188720"/>
           </a:xfrm>
           <a:prstGeom prst="ellipse">
             <a:avLst/>
           </a:prstGeom>
           <a:solidFill>
-            <a:srgbClr val="FFFFFF"/>
+            <a:srgbClr val="FFFFFF">
+              <a:alpha val="0"/>
+            </a:srgbClr>
           </a:solidFill>
-          <a:ln/>
-        </p:spPr>
-      </p:sp>
-      <p:sp>
-        <p:nvSpPr>
-          <p:cNvPr id="7" name="Text 5"/>
-          <p:cNvSpPr txBox="1"/>
-          <p:nvPr/>
-        </p:nvSpPr>
-        <p:spPr>
-          <a:xfrm>
-            <a:off x="1097280" y="2788920"/>
-            <a:ext cx="1005840" cy="1005840"/>
-          </a:xfrm>
-          <a:prstGeom prst="rect">
-            <a:avLst/>
-          </a:prstGeom>
-          <a:noFill/>
-          <a:ln/>
-        </p:spPr>
-        <p:txBody>
-          <a:bodyPr wrap="square" lIns="0" tIns="0" rIns="0" bIns="0" rtlCol="0" anchor="ctr"/>
+          <a:ln w="19050">
+            <a:solidFill>
+              <a:srgbClr val="262626"/>
+            </a:solidFill>
+            <a:prstDash val="solid"/>
+          </a:ln>
+        </p:spPr>
+      </p:sp>
+      <p:sp>
+        <p:nvSpPr>
+          <p:cNvPr id="8" name="Text 5"/>
+          <p:cNvSpPr txBox="1"/>
+          <p:nvPr/>
+        </p:nvSpPr>
+        <p:spPr>
+          <a:xfrm>
+            <a:off x="731520" y="3977640"/>
+            <a:ext cx="1737360" cy="685800"/>
+          </a:xfrm>
+          <a:prstGeom prst="rect">
+            <a:avLst/>
+          </a:prstGeom>
+          <a:noFill/>
+          <a:ln/>
+        </p:spPr>
+        <p:txBody>
+          <a:bodyPr wrap="square" lIns="0" tIns="0" rIns="0" bIns="0" rtlCol="0" anchor="t"/>
           <a:lstStyle/>
           <a:p>
             <a:pPr algn="ctr" indent="0" marL="0">
               <a:buNone/>
             </a:pPr>
             <a:r>
-              <a:rPr lang="en-US" sz="2600" dirty="0">
-                <a:solidFill>
-                  <a:srgbClr val="0A0A0A"/>
+              <a:rPr lang="en-US" sz="1600" dirty="0">
+                <a:solidFill>
+                  <a:srgbClr val="FFFFFF"/>
                 </a:solidFill>
                 <a:latin typeface="Segoe UI Semibold" pitchFamily="34" charset="0"/>
                 <a:ea typeface="Segoe UI Semibold" pitchFamily="34" charset="-122"/>
                 <a:cs typeface="Segoe UI Semibold" pitchFamily="34" charset="-120"/>
               </a:rPr>
-              <a:t>AD</a:t>
-            </a:r>
-            <a:endParaRPr lang="en-US" sz="2600" dirty="0"/>
-          </a:p>
-        </p:txBody>
-      </p:sp>
-      <p:sp>
-        <p:nvSpPr>
-          <p:cNvPr id="8" name="Text 6"/>
-          <p:cNvSpPr txBox="1"/>
-          <p:nvPr/>
-        </p:nvSpPr>
-        <p:spPr>
-          <a:xfrm>
-            <a:off x="731520" y="4114800"/>
-            <a:ext cx="1737360" cy="685800"/>
-          </a:xfrm>
-          <a:prstGeom prst="rect">
-            <a:avLst/>
-          </a:prstGeom>
-          <a:noFill/>
-          <a:ln/>
-        </p:spPr>
-        <p:txBody>
-          <a:bodyPr wrap="square" lIns="0" tIns="0" rIns="0" bIns="0" rtlCol="0" anchor="t"/>
-          <a:lstStyle/>
-          <a:p>
-            <a:pPr algn="ctr" indent="0" marL="0">
-              <a:buNone/>
-            </a:pPr>
-            <a:r>
-              <a:rPr lang="en-US" sz="1600" dirty="0">
-                <a:solidFill>
-                  <a:srgbClr val="FFFFFF"/>
-                </a:solidFill>
-                <a:latin typeface="Segoe UI Semibold" pitchFamily="34" charset="0"/>
-                <a:ea typeface="Segoe UI Semibold" pitchFamily="34" charset="-122"/>
-                <a:cs typeface="Segoe UI Semibold" pitchFamily="34" charset="-120"/>
-              </a:rPr>
               <a:t>Azrian Dalimunthe</a:t>
             </a:r>
             <a:endParaRPr lang="en-US" sz="1600" dirty="0"/>
@@ -12856,13 +12848,13 @@
       </p:sp>
       <p:sp>
         <p:nvSpPr>
-          <p:cNvPr id="9" name="Shape 7"/>
+          <p:cNvPr id="9" name="Shape 6"/>
           <p:cNvSpPr/>
           <p:nvPr/>
         </p:nvSpPr>
         <p:spPr>
           <a:xfrm>
-            <a:off x="1014984" y="4709160"/>
+            <a:off x="1014984" y="4572000"/>
             <a:ext cx="1172261" cy="292608"/>
           </a:xfrm>
           <a:prstGeom prst="roundRect">
@@ -12878,13 +12870,13 @@
       </p:sp>
       <p:sp>
         <p:nvSpPr>
-          <p:cNvPr id="10" name="Text 8"/>
-          <p:cNvSpPr txBox="1"/>
-          <p:nvPr/>
-        </p:nvSpPr>
-        <p:spPr>
-          <a:xfrm>
-            <a:off x="1014984" y="4709160"/>
+          <p:cNvPr id="10" name="Text 7"/>
+          <p:cNvSpPr txBox="1"/>
+          <p:nvPr/>
+        </p:nvSpPr>
+        <p:spPr>
+          <a:xfrm>
+            <a:off x="1014984" y="4572000"/>
             <a:ext cx="1172261" cy="292608"/>
           </a:xfrm>
           <a:prstGeom prst="rect">
@@ -12917,7 +12909,7 @@
       </p:sp>
       <p:sp>
         <p:nvSpPr>
-          <p:cNvPr id="11" name="Shape 9"/>
+          <p:cNvPr id="11" name="Shape 8"/>
           <p:cNvSpPr/>
           <p:nvPr/>
         </p:nvSpPr>
@@ -12937,98 +12929,90 @@
           <a:ln/>
         </p:spPr>
       </p:sp>
-      <p:sp>
-        <p:nvSpPr>
-          <p:cNvPr id="12" name="Shape 10"/>
+      <p:pic>
+        <p:nvPicPr>
+          <p:cNvPr id="12" name="Image 1" descr="Foto profil Doni Anggara">    </p:cNvPr>
+          <p:cNvPicPr>
+            <a:picLocks noChangeAspect="1"/>
+          </p:cNvPicPr>
+          <p:nvPr/>
+        </p:nvPicPr>
+        <p:blipFill>
+          <a:blip r:embed="rId2"/>
+          <a:stretch>
+            <a:fillRect/>
+          </a:stretch>
+        </p:blipFill>
+        <p:spPr>
+          <a:xfrm>
+            <a:off x="3273552" y="2514600"/>
+            <a:ext cx="1188720" cy="1188720"/>
+          </a:xfrm>
+          <a:prstGeom prst="rect">
+            <a:avLst/>
+          </a:prstGeom>
+        </p:spPr>
+      </p:pic>
+      <p:sp>
+        <p:nvSpPr>
+          <p:cNvPr id="13" name="Shape 9"/>
           <p:cNvSpPr/>
           <p:nvPr/>
         </p:nvSpPr>
         <p:spPr>
           <a:xfrm>
-            <a:off x="3364992" y="2788920"/>
-            <a:ext cx="1005840" cy="1005840"/>
+            <a:off x="3273552" y="2514600"/>
+            <a:ext cx="1188720" cy="1188720"/>
           </a:xfrm>
           <a:prstGeom prst="ellipse">
             <a:avLst/>
           </a:prstGeom>
           <a:solidFill>
-            <a:srgbClr val="0A0A0A"/>
+            <a:srgbClr val="FFFFFF">
+              <a:alpha val="0"/>
+            </a:srgbClr>
           </a:solidFill>
-          <a:ln/>
-        </p:spPr>
-      </p:sp>
-      <p:sp>
-        <p:nvSpPr>
-          <p:cNvPr id="13" name="Text 11"/>
-          <p:cNvSpPr txBox="1"/>
-          <p:nvPr/>
-        </p:nvSpPr>
-        <p:spPr>
-          <a:xfrm>
-            <a:off x="3364992" y="2788920"/>
-            <a:ext cx="1005840" cy="1005840"/>
-          </a:xfrm>
-          <a:prstGeom prst="rect">
-            <a:avLst/>
-          </a:prstGeom>
-          <a:noFill/>
-          <a:ln/>
-        </p:spPr>
-        <p:txBody>
-          <a:bodyPr wrap="square" lIns="0" tIns="0" rIns="0" bIns="0" rtlCol="0" anchor="ctr"/>
+          <a:ln w="19050">
+            <a:solidFill>
+              <a:srgbClr val="D4D4D4"/>
+            </a:solidFill>
+            <a:prstDash val="solid"/>
+          </a:ln>
+        </p:spPr>
+      </p:sp>
+      <p:sp>
+        <p:nvSpPr>
+          <p:cNvPr id="14" name="Text 10"/>
+          <p:cNvSpPr txBox="1"/>
+          <p:nvPr/>
+        </p:nvSpPr>
+        <p:spPr>
+          <a:xfrm>
+            <a:off x="2999232" y="3977640"/>
+            <a:ext cx="1737360" cy="685800"/>
+          </a:xfrm>
+          <a:prstGeom prst="rect">
+            <a:avLst/>
+          </a:prstGeom>
+          <a:noFill/>
+          <a:ln/>
+        </p:spPr>
+        <p:txBody>
+          <a:bodyPr wrap="square" lIns="0" tIns="0" rIns="0" bIns="0" rtlCol="0" anchor="t"/>
           <a:lstStyle/>
           <a:p>
             <a:pPr algn="ctr" indent="0" marL="0">
               <a:buNone/>
             </a:pPr>
             <a:r>
-              <a:rPr lang="en-US" sz="2600" dirty="0">
-                <a:solidFill>
-                  <a:srgbClr val="FFFFFF"/>
+              <a:rPr lang="en-US" sz="1600" dirty="0">
+                <a:solidFill>
+                  <a:srgbClr val="0A0A0A"/>
                 </a:solidFill>
                 <a:latin typeface="Segoe UI Semibold" pitchFamily="34" charset="0"/>
                 <a:ea typeface="Segoe UI Semibold" pitchFamily="34" charset="-122"/>
                 <a:cs typeface="Segoe UI Semibold" pitchFamily="34" charset="-120"/>
               </a:rPr>
-              <a:t>DA</a:t>
-            </a:r>
-            <a:endParaRPr lang="en-US" sz="2600" dirty="0"/>
-          </a:p>
-        </p:txBody>
-      </p:sp>
-      <p:sp>
-        <p:nvSpPr>
-          <p:cNvPr id="14" name="Text 12"/>
-          <p:cNvSpPr txBox="1"/>
-          <p:nvPr/>
-        </p:nvSpPr>
-        <p:spPr>
-          <a:xfrm>
-            <a:off x="2999232" y="4114800"/>
-            <a:ext cx="1737360" cy="685800"/>
-          </a:xfrm>
-          <a:prstGeom prst="rect">
-            <a:avLst/>
-          </a:prstGeom>
-          <a:noFill/>
-          <a:ln/>
-        </p:spPr>
-        <p:txBody>
-          <a:bodyPr wrap="square" lIns="0" tIns="0" rIns="0" bIns="0" rtlCol="0" anchor="t"/>
-          <a:lstStyle/>
-          <a:p>
-            <a:pPr algn="ctr" indent="0" marL="0">
-              <a:buNone/>
-            </a:pPr>
-            <a:r>
-              <a:rPr lang="en-US" sz="1600" dirty="0">
-                <a:solidFill>
-                  <a:srgbClr val="0A0A0A"/>
-                </a:solidFill>
-                <a:latin typeface="Segoe UI Semibold" pitchFamily="34" charset="0"/>
-                <a:ea typeface="Segoe UI Semibold" pitchFamily="34" charset="-122"/>
-                <a:cs typeface="Segoe UI Semibold" pitchFamily="34" charset="-120"/>
-              </a:rPr>
               <a:t>Doni Anggara</a:t>
             </a:r>
             <a:endParaRPr lang="en-US" sz="1600" dirty="0"/>
@@ -13037,7 +13021,7 @@
       </p:sp>
       <p:sp>
         <p:nvSpPr>
-          <p:cNvPr id="15" name="Shape 13"/>
+          <p:cNvPr id="15" name="Shape 11"/>
           <p:cNvSpPr/>
           <p:nvPr/>
         </p:nvSpPr>
@@ -13057,98 +13041,90 @@
           <a:ln/>
         </p:spPr>
       </p:sp>
-      <p:sp>
-        <p:nvSpPr>
-          <p:cNvPr id="16" name="Shape 14"/>
+      <p:pic>
+        <p:nvPicPr>
+          <p:cNvPr id="16" name="Image 2" descr="Foto profil Kevin Ilham">    </p:cNvPr>
+          <p:cNvPicPr>
+            <a:picLocks noChangeAspect="1"/>
+          </p:cNvPicPr>
+          <p:nvPr/>
+        </p:nvPicPr>
+        <p:blipFill>
+          <a:blip r:embed="rId3"/>
+          <a:stretch>
+            <a:fillRect/>
+          </a:stretch>
+        </p:blipFill>
+        <p:spPr>
+          <a:xfrm>
+            <a:off x="5541264" y="2514600"/>
+            <a:ext cx="1188720" cy="1188720"/>
+          </a:xfrm>
+          <a:prstGeom prst="rect">
+            <a:avLst/>
+          </a:prstGeom>
+        </p:spPr>
+      </p:pic>
+      <p:sp>
+        <p:nvSpPr>
+          <p:cNvPr id="17" name="Shape 12"/>
           <p:cNvSpPr/>
           <p:nvPr/>
         </p:nvSpPr>
         <p:spPr>
           <a:xfrm>
-            <a:off x="5632704" y="2788920"/>
-            <a:ext cx="1005840" cy="1005840"/>
+            <a:off x="5541264" y="2514600"/>
+            <a:ext cx="1188720" cy="1188720"/>
           </a:xfrm>
           <a:prstGeom prst="ellipse">
             <a:avLst/>
           </a:prstGeom>
           <a:solidFill>
-            <a:srgbClr val="0A0A0A"/>
+            <a:srgbClr val="FFFFFF">
+              <a:alpha val="0"/>
+            </a:srgbClr>
           </a:solidFill>
-          <a:ln/>
-        </p:spPr>
-      </p:sp>
-      <p:sp>
-        <p:nvSpPr>
-          <p:cNvPr id="17" name="Text 15"/>
-          <p:cNvSpPr txBox="1"/>
-          <p:nvPr/>
-        </p:nvSpPr>
-        <p:spPr>
-          <a:xfrm>
-            <a:off x="5632704" y="2788920"/>
-            <a:ext cx="1005840" cy="1005840"/>
-          </a:xfrm>
-          <a:prstGeom prst="rect">
-            <a:avLst/>
-          </a:prstGeom>
-          <a:noFill/>
-          <a:ln/>
-        </p:spPr>
-        <p:txBody>
-          <a:bodyPr wrap="square" lIns="0" tIns="0" rIns="0" bIns="0" rtlCol="0" anchor="ctr"/>
+          <a:ln w="19050">
+            <a:solidFill>
+              <a:srgbClr val="D4D4D4"/>
+            </a:solidFill>
+            <a:prstDash val="solid"/>
+          </a:ln>
+        </p:spPr>
+      </p:sp>
+      <p:sp>
+        <p:nvSpPr>
+          <p:cNvPr id="18" name="Text 13"/>
+          <p:cNvSpPr txBox="1"/>
+          <p:nvPr/>
+        </p:nvSpPr>
+        <p:spPr>
+          <a:xfrm>
+            <a:off x="5266944" y="3977640"/>
+            <a:ext cx="1737360" cy="685800"/>
+          </a:xfrm>
+          <a:prstGeom prst="rect">
+            <a:avLst/>
+          </a:prstGeom>
+          <a:noFill/>
+          <a:ln/>
+        </p:spPr>
+        <p:txBody>
+          <a:bodyPr wrap="square" lIns="0" tIns="0" rIns="0" bIns="0" rtlCol="0" anchor="t"/>
           <a:lstStyle/>
           <a:p>
             <a:pPr algn="ctr" indent="0" marL="0">
               <a:buNone/>
             </a:pPr>
             <a:r>
-              <a:rPr lang="en-US" sz="2600" dirty="0">
-                <a:solidFill>
-                  <a:srgbClr val="FFFFFF"/>
+              <a:rPr lang="en-US" sz="1600" dirty="0">
+                <a:solidFill>
+                  <a:srgbClr val="0A0A0A"/>
                 </a:solidFill>
                 <a:latin typeface="Segoe UI Semibold" pitchFamily="34" charset="0"/>
                 <a:ea typeface="Segoe UI Semibold" pitchFamily="34" charset="-122"/>
                 <a:cs typeface="Segoe UI Semibold" pitchFamily="34" charset="-120"/>
               </a:rPr>
-              <a:t>KI</a:t>
-            </a:r>
-            <a:endParaRPr lang="en-US" sz="2600" dirty="0"/>
-          </a:p>
-        </p:txBody>
-      </p:sp>
-      <p:sp>
-        <p:nvSpPr>
-          <p:cNvPr id="18" name="Text 16"/>
-          <p:cNvSpPr txBox="1"/>
-          <p:nvPr/>
-        </p:nvSpPr>
-        <p:spPr>
-          <a:xfrm>
-            <a:off x="5266944" y="4114800"/>
-            <a:ext cx="1737360" cy="685800"/>
-          </a:xfrm>
-          <a:prstGeom prst="rect">
-            <a:avLst/>
-          </a:prstGeom>
-          <a:noFill/>
-          <a:ln/>
-        </p:spPr>
-        <p:txBody>
-          <a:bodyPr wrap="square" lIns="0" tIns="0" rIns="0" bIns="0" rtlCol="0" anchor="t"/>
-          <a:lstStyle/>
-          <a:p>
-            <a:pPr algn="ctr" indent="0" marL="0">
-              <a:buNone/>
-            </a:pPr>
-            <a:r>
-              <a:rPr lang="en-US" sz="1600" dirty="0">
-                <a:solidFill>
-                  <a:srgbClr val="0A0A0A"/>
-                </a:solidFill>
-                <a:latin typeface="Segoe UI Semibold" pitchFamily="34" charset="0"/>
-                <a:ea typeface="Segoe UI Semibold" pitchFamily="34" charset="-122"/>
-                <a:cs typeface="Segoe UI Semibold" pitchFamily="34" charset="-120"/>
-              </a:rPr>
               <a:t>Kevin Ilham</a:t>
             </a:r>
             <a:endParaRPr lang="en-US" sz="1600" dirty="0"/>
@@ -13157,7 +13133,7 @@
       </p:sp>
       <p:sp>
         <p:nvSpPr>
-          <p:cNvPr id="19" name="Shape 17"/>
+          <p:cNvPr id="19" name="Shape 14"/>
           <p:cNvSpPr/>
           <p:nvPr/>
         </p:nvSpPr>
@@ -13177,98 +13153,90 @@
           <a:ln/>
         </p:spPr>
       </p:sp>
-      <p:sp>
-        <p:nvSpPr>
-          <p:cNvPr id="20" name="Shape 18"/>
+      <p:pic>
+        <p:nvPicPr>
+          <p:cNvPr id="20" name="Image 3" descr="Foto profil Rizki Kusnadi">    </p:cNvPr>
+          <p:cNvPicPr>
+            <a:picLocks noChangeAspect="1"/>
+          </p:cNvPicPr>
+          <p:nvPr/>
+        </p:nvPicPr>
+        <p:blipFill>
+          <a:blip r:embed="rId4"/>
+          <a:stretch>
+            <a:fillRect/>
+          </a:stretch>
+        </p:blipFill>
+        <p:spPr>
+          <a:xfrm>
+            <a:off x="7808976" y="2514600"/>
+            <a:ext cx="1188720" cy="1188720"/>
+          </a:xfrm>
+          <a:prstGeom prst="rect">
+            <a:avLst/>
+          </a:prstGeom>
+        </p:spPr>
+      </p:pic>
+      <p:sp>
+        <p:nvSpPr>
+          <p:cNvPr id="21" name="Shape 15"/>
           <p:cNvSpPr/>
           <p:nvPr/>
         </p:nvSpPr>
         <p:spPr>
           <a:xfrm>
-            <a:off x="7900416" y="2788920"/>
-            <a:ext cx="1005840" cy="1005840"/>
+            <a:off x="7808976" y="2514600"/>
+            <a:ext cx="1188720" cy="1188720"/>
           </a:xfrm>
           <a:prstGeom prst="ellipse">
             <a:avLst/>
           </a:prstGeom>
           <a:solidFill>
-            <a:srgbClr val="0A0A0A"/>
+            <a:srgbClr val="FFFFFF">
+              <a:alpha val="0"/>
+            </a:srgbClr>
           </a:solidFill>
-          <a:ln/>
-        </p:spPr>
-      </p:sp>
-      <p:sp>
-        <p:nvSpPr>
-          <p:cNvPr id="21" name="Text 19"/>
-          <p:cNvSpPr txBox="1"/>
-          <p:nvPr/>
-        </p:nvSpPr>
-        <p:spPr>
-          <a:xfrm>
-            <a:off x="7900416" y="2788920"/>
-            <a:ext cx="1005840" cy="1005840"/>
-          </a:xfrm>
-          <a:prstGeom prst="rect">
-            <a:avLst/>
-          </a:prstGeom>
-          <a:noFill/>
-          <a:ln/>
-        </p:spPr>
-        <p:txBody>
-          <a:bodyPr wrap="square" lIns="0" tIns="0" rIns="0" bIns="0" rtlCol="0" anchor="ctr"/>
+          <a:ln w="19050">
+            <a:solidFill>
+              <a:srgbClr val="D4D4D4"/>
+            </a:solidFill>
+            <a:prstDash val="solid"/>
+          </a:ln>
+        </p:spPr>
+      </p:sp>
+      <p:sp>
+        <p:nvSpPr>
+          <p:cNvPr id="22" name="Text 16"/>
+          <p:cNvSpPr txBox="1"/>
+          <p:nvPr/>
+        </p:nvSpPr>
+        <p:spPr>
+          <a:xfrm>
+            <a:off x="7534656" y="3977640"/>
+            <a:ext cx="1737360" cy="685800"/>
+          </a:xfrm>
+          <a:prstGeom prst="rect">
+            <a:avLst/>
+          </a:prstGeom>
+          <a:noFill/>
+          <a:ln/>
+        </p:spPr>
+        <p:txBody>
+          <a:bodyPr wrap="square" lIns="0" tIns="0" rIns="0" bIns="0" rtlCol="0" anchor="t"/>
           <a:lstStyle/>
           <a:p>
             <a:pPr algn="ctr" indent="0" marL="0">
               <a:buNone/>
             </a:pPr>
             <a:r>
-              <a:rPr lang="en-US" sz="2600" dirty="0">
-                <a:solidFill>
-                  <a:srgbClr val="FFFFFF"/>
+              <a:rPr lang="en-US" sz="1600" dirty="0">
+                <a:solidFill>
+                  <a:srgbClr val="0A0A0A"/>
                 </a:solidFill>
                 <a:latin typeface="Segoe UI Semibold" pitchFamily="34" charset="0"/>
                 <a:ea typeface="Segoe UI Semibold" pitchFamily="34" charset="-122"/>
                 <a:cs typeface="Segoe UI Semibold" pitchFamily="34" charset="-120"/>
               </a:rPr>
-              <a:t>RK</a:t>
-            </a:r>
-            <a:endParaRPr lang="en-US" sz="2600" dirty="0"/>
-          </a:p>
-        </p:txBody>
-      </p:sp>
-      <p:sp>
-        <p:nvSpPr>
-          <p:cNvPr id="22" name="Text 20"/>
-          <p:cNvSpPr txBox="1"/>
-          <p:nvPr/>
-        </p:nvSpPr>
-        <p:spPr>
-          <a:xfrm>
-            <a:off x="7534656" y="4114800"/>
-            <a:ext cx="1737360" cy="685800"/>
-          </a:xfrm>
-          <a:prstGeom prst="rect">
-            <a:avLst/>
-          </a:prstGeom>
-          <a:noFill/>
-          <a:ln/>
-        </p:spPr>
-        <p:txBody>
-          <a:bodyPr wrap="square" lIns="0" tIns="0" rIns="0" bIns="0" rtlCol="0" anchor="t"/>
-          <a:lstStyle/>
-          <a:p>
-            <a:pPr algn="ctr" indent="0" marL="0">
-              <a:buNone/>
-            </a:pPr>
-            <a:r>
-              <a:rPr lang="en-US" sz="1600" dirty="0">
-                <a:solidFill>
-                  <a:srgbClr val="0A0A0A"/>
-                </a:solidFill>
-                <a:latin typeface="Segoe UI Semibold" pitchFamily="34" charset="0"/>
-                <a:ea typeface="Segoe UI Semibold" pitchFamily="34" charset="-122"/>
-                <a:cs typeface="Segoe UI Semibold" pitchFamily="34" charset="-120"/>
-              </a:rPr>
               <a:t>Rizki Kusnadi</a:t>
             </a:r>
             <a:endParaRPr lang="en-US" sz="1600" dirty="0"/>
@@ -13277,7 +13245,7 @@
       </p:sp>
       <p:sp>
         <p:nvSpPr>
-          <p:cNvPr id="23" name="Shape 21"/>
+          <p:cNvPr id="23" name="Shape 17"/>
           <p:cNvSpPr/>
           <p:nvPr/>
         </p:nvSpPr>
@@ -13297,74 +13265,66 @@
           <a:ln/>
         </p:spPr>
       </p:sp>
-      <p:sp>
-        <p:nvSpPr>
-          <p:cNvPr id="24" name="Shape 22"/>
+      <p:pic>
+        <p:nvPicPr>
+          <p:cNvPr id="24" name="Image 4" descr="Foto profil Zulfikar Satya Nugraha">    </p:cNvPr>
+          <p:cNvPicPr>
+            <a:picLocks noChangeAspect="1"/>
+          </p:cNvPicPr>
+          <p:nvPr/>
+        </p:nvPicPr>
+        <p:blipFill>
+          <a:blip r:embed="rId5"/>
+          <a:stretch>
+            <a:fillRect/>
+          </a:stretch>
+        </p:blipFill>
+        <p:spPr>
+          <a:xfrm>
+            <a:off x="10076688" y="2514600"/>
+            <a:ext cx="1188720" cy="1188720"/>
+          </a:xfrm>
+          <a:prstGeom prst="rect">
+            <a:avLst/>
+          </a:prstGeom>
+        </p:spPr>
+      </p:pic>
+      <p:sp>
+        <p:nvSpPr>
+          <p:cNvPr id="25" name="Shape 18"/>
           <p:cNvSpPr/>
           <p:nvPr/>
         </p:nvSpPr>
         <p:spPr>
           <a:xfrm>
-            <a:off x="10168128" y="2788920"/>
-            <a:ext cx="1005840" cy="1005840"/>
+            <a:off x="10076688" y="2514600"/>
+            <a:ext cx="1188720" cy="1188720"/>
           </a:xfrm>
           <a:prstGeom prst="ellipse">
             <a:avLst/>
           </a:prstGeom>
           <a:solidFill>
-            <a:srgbClr val="0A0A0A"/>
+            <a:srgbClr val="FFFFFF">
+              <a:alpha val="0"/>
+            </a:srgbClr>
           </a:solidFill>
-          <a:ln/>
-        </p:spPr>
-      </p:sp>
-      <p:sp>
-        <p:nvSpPr>
-          <p:cNvPr id="25" name="Text 23"/>
-          <p:cNvSpPr txBox="1"/>
-          <p:nvPr/>
-        </p:nvSpPr>
-        <p:spPr>
-          <a:xfrm>
-            <a:off x="10168128" y="2788920"/>
-            <a:ext cx="1005840" cy="1005840"/>
-          </a:xfrm>
-          <a:prstGeom prst="rect">
-            <a:avLst/>
-          </a:prstGeom>
-          <a:noFill/>
-          <a:ln/>
-        </p:spPr>
-        <p:txBody>
-          <a:bodyPr wrap="square" lIns="0" tIns="0" rIns="0" bIns="0" rtlCol="0" anchor="ctr"/>
-          <a:lstStyle/>
-          <a:p>
-            <a:pPr algn="ctr" indent="0" marL="0">
-              <a:buNone/>
-            </a:pPr>
-            <a:r>
-              <a:rPr lang="en-US" sz="2600" dirty="0">
-                <a:solidFill>
-                  <a:srgbClr val="FFFFFF"/>
-                </a:solidFill>
-                <a:latin typeface="Segoe UI Semibold" pitchFamily="34" charset="0"/>
-                <a:ea typeface="Segoe UI Semibold" pitchFamily="34" charset="-122"/>
-                <a:cs typeface="Segoe UI Semibold" pitchFamily="34" charset="-120"/>
-              </a:rPr>
-              <a:t>ZS</a:t>
-            </a:r>
-            <a:endParaRPr lang="en-US" sz="2600" dirty="0"/>
-          </a:p>
-        </p:txBody>
-      </p:sp>
-      <p:sp>
-        <p:nvSpPr>
-          <p:cNvPr id="26" name="Text 24"/>
-          <p:cNvSpPr txBox="1"/>
-          <p:nvPr/>
-        </p:nvSpPr>
-        <p:spPr>
-          <a:xfrm>
-            <a:off x="9802368" y="4114800"/>
+          <a:ln w="19050">
+            <a:solidFill>
+              <a:srgbClr val="D4D4D4"/>
+            </a:solidFill>
+            <a:prstDash val="solid"/>
+          </a:ln>
+        </p:spPr>
+      </p:sp>
+      <p:sp>
+        <p:nvSpPr>
+          <p:cNvPr id="26" name="Text 19"/>
+          <p:cNvSpPr txBox="1"/>
+          <p:nvPr/>
+        </p:nvSpPr>
+        <p:spPr>
+          <a:xfrm>
+            <a:off x="9802368" y="3977640"/>
             <a:ext cx="1737360" cy="685800"/>
           </a:xfrm>
           <a:prstGeom prst="rect">

</xml_diff>

<commit_message>
docs: PPT slide anggota menampilkan tautan GitHub tiap anggota
Tautan kecil github.com/<akun> di bawah nama, bisa diklik di PPT dan PDF.
Nama dan tautan dalam satu kotak teks agar tautan ikut turun bila nama
dua baris.

Co-Authored-By: Claude <noreply@anthropic.com>
</commit_message>
<xml_diff>
--- a/docs/Presentasi_ECommerce_TokoKita.pptx
+++ b/docs/Presentasi_ECommerce_TokoKita.pptx
@@ -131,21 +131,21 @@
   <p:extLst>
     <p:ext uri="{521415D9-36F7-43E2-AB2F-B90AF26B5E84}">
       <p14:sectionLst xmlns:p14="http://schemas.microsoft.com/office/powerpoint/2010/main">
-        <p14:section name="Pembuka" id="{76f61e40-1215-abdf-4e2b-43a2087cf575}">
+        <p14:section name="Pembuka" id="{66d9230b-7cbc-d6b7-842a-f198604fd437}">
           <p14:sldIdLst>
             <p14:sldId id="256"/>
             <p14:sldId id="257"/>
             <p14:sldId id="258"/>
           </p14:sldIdLst>
         </p14:section>
-        <p14:section name="Latar &amp; cakupan" id="{5e0d4aa8-2005-7aea-464d-664dc16751bb}">
+        <p14:section name="Latar &amp; cakupan" id="{1c629e85-efc0-8458-a924-194624abc597}">
           <p14:sldIdLst>
             <p14:sldId id="259"/>
             <p14:sldId id="260"/>
             <p14:sldId id="261"/>
           </p14:sldIdLst>
         </p14:section>
-        <p14:section name="Teknologi" id="{d41a3be1-973e-df31-f279-f82c47091f10}">
+        <p14:section name="Teknologi" id="{849f2692-5273-0c64-cc2f-deb2d4a21512}">
           <p14:sldIdLst>
             <p14:sldId id="262"/>
             <p14:sldId id="263"/>
@@ -154,7 +154,7 @@
             <p14:sldId id="266"/>
           </p14:sldIdLst>
         </p14:section>
-        <p14:section name="Tampilan aplikasi" id="{0067de09-c7dd-76aa-5fd7-a6afdca7bb38}">
+        <p14:section name="Tampilan aplikasi" id="{b2c3a994-d0db-ef1b-593a-33dc916aecad}">
           <p14:sldIdLst>
             <p14:sldId id="267"/>
             <p14:sldId id="268"/>
@@ -164,13 +164,13 @@
             <p14:sldId id="272"/>
           </p14:sldIdLst>
         </p14:section>
-        <p14:section name="Tim &amp; cara kerja" id="{829c44b4-74d9-bc26-e54b-14d123487a35}">
+        <p14:section name="Tim &amp; cara kerja" id="{7cdaff80-a575-7758-4b14-68c3e9687858}">
           <p14:sldIdLst>
             <p14:sldId id="273"/>
             <p14:sldId id="274"/>
           </p14:sldIdLst>
         </p14:section>
-        <p14:section name="Kualitas &amp; demo" id="{b4f2d86c-c16d-7502-dbf9-5802f1e1d7a4}">
+        <p14:section name="Kualitas &amp; demo" id="{a4ca9daf-00f6-6993-6618-2685416aebd3}">
           <p14:sldIdLst>
             <p14:sldId id="275"/>
             <p14:sldId id="276"/>
@@ -179,7 +179,7 @@
             <p14:sldId id="279"/>
           </p14:sldIdLst>
         </p14:section>
-        <p14:section name="Penutup" id="{2d3a8fbb-e102-4f8a-b6a8-a6e6f1837ffb}">
+        <p14:section name="Penutup" id="{1b66c9fe-d51e-478e-204d-32b47d9c5eae}">
           <p14:sldIdLst>
             <p14:sldId id="280"/>
           </p14:sldIdLst>
@@ -12815,8 +12815,8 @@
         </p:nvSpPr>
         <p:spPr>
           <a:xfrm>
-            <a:off x="731520" y="3977640"/>
-            <a:ext cx="1737360" cy="685800"/>
+            <a:off x="640080" y="3977640"/>
+            <a:ext cx="1920240" cy="914400"/>
           </a:xfrm>
           <a:prstGeom prst="rect">
             <a:avLst/>
@@ -12829,6 +12829,9 @@
           <a:lstStyle/>
           <a:p>
             <a:pPr algn="ctr" indent="0" marL="0">
+              <a:spcAft>
+                <a:spcPts val="400"/>
+              </a:spcAft>
               <a:buNone/>
             </a:pPr>
             <a:r>
@@ -12842,7 +12845,34 @@
               </a:rPr>
               <a:t>Azrian Dalimunthe</a:t>
             </a:r>
-            <a:endParaRPr lang="en-US" sz="1600" dirty="0"/>
+            <a:endParaRPr lang="en-US" sz="1300" dirty="0"/>
+          </a:p>
+          <a:p>
+            <a:pPr algn="ctr" indent="0" marL="0">
+              <a:spcAft>
+                <a:spcPts val="400"/>
+              </a:spcAft>
+              <a:buNone/>
+            </a:pPr>
+            <a:r>
+              <a:rPr lang="en-US" sz="1000" u="sng" dirty="0">
+                <a:solidFill>
+                  <a:srgbClr val="A3A3A3"/>
+                </a:solidFill>
+                <a:latin typeface="Segoe UI" pitchFamily="34" charset="0"/>
+                <a:ea typeface="Segoe UI" pitchFamily="34" charset="-122"/>
+                <a:cs typeface="Segoe UI" pitchFamily="34" charset="-120"/>
+                <a:hlinkClick r:id="rId2" invalidUrl="" action="" tgtFrame="" tooltip="Profil GitHub Azrian Dalimunthe" history="1" highlightClick="0" endSnd="0">
+                  <a:extLst>
+                    <a:ext uri="{A12FA001-AC4F-418D-AE19-62706E023703}">
+                      <ahyp:hlinkClr xmlns:ahyp="http://schemas.microsoft.com/office/drawing/2018/hyperlinkcolor" val="tx"/>
+                    </a:ext>
+                  </a:extLst>
+                </a:hlinkClick>
+              </a:rPr>
+              <a:t>github.com/azridalimunthe7</a:t>
+            </a:r>
+            <a:endParaRPr lang="en-US" sz="1300" dirty="0"/>
           </a:p>
         </p:txBody>
       </p:sp>
@@ -12854,7 +12884,7 @@
         </p:nvSpPr>
         <p:spPr>
           <a:xfrm>
-            <a:off x="1014984" y="4572000"/>
+            <a:off x="1014984" y="4663440"/>
             <a:ext cx="1172261" cy="292608"/>
           </a:xfrm>
           <a:prstGeom prst="roundRect">
@@ -12876,7 +12906,7 @@
         </p:nvSpPr>
         <p:spPr>
           <a:xfrm>
-            <a:off x="1014984" y="4572000"/>
+            <a:off x="1014984" y="4663440"/>
             <a:ext cx="1172261" cy="292608"/>
           </a:xfrm>
           <a:prstGeom prst="rect">
@@ -12938,7 +12968,7 @@
           <p:nvPr/>
         </p:nvPicPr>
         <p:blipFill>
-          <a:blip r:embed="rId2"/>
+          <a:blip r:embed="rId3"/>
           <a:stretch>
             <a:fillRect/>
           </a:stretch>
@@ -12988,8 +13018,8 @@
         </p:nvSpPr>
         <p:spPr>
           <a:xfrm>
-            <a:off x="2999232" y="3977640"/>
-            <a:ext cx="1737360" cy="685800"/>
+            <a:off x="2907792" y="3977640"/>
+            <a:ext cx="1920240" cy="914400"/>
           </a:xfrm>
           <a:prstGeom prst="rect">
             <a:avLst/>
@@ -13002,6 +13032,9 @@
           <a:lstStyle/>
           <a:p>
             <a:pPr algn="ctr" indent="0" marL="0">
+              <a:spcAft>
+                <a:spcPts val="400"/>
+              </a:spcAft>
               <a:buNone/>
             </a:pPr>
             <a:r>
@@ -13015,7 +13048,34 @@
               </a:rPr>
               <a:t>Doni Anggara</a:t>
             </a:r>
-            <a:endParaRPr lang="en-US" sz="1600" dirty="0"/>
+            <a:endParaRPr lang="en-US" sz="1300" dirty="0"/>
+          </a:p>
+          <a:p>
+            <a:pPr algn="ctr" indent="0" marL="0">
+              <a:spcAft>
+                <a:spcPts val="400"/>
+              </a:spcAft>
+              <a:buNone/>
+            </a:pPr>
+            <a:r>
+              <a:rPr lang="en-US" sz="1000" u="sng" dirty="0">
+                <a:solidFill>
+                  <a:srgbClr val="5C5C5C"/>
+                </a:solidFill>
+                <a:latin typeface="Segoe UI" pitchFamily="34" charset="0"/>
+                <a:ea typeface="Segoe UI" pitchFamily="34" charset="-122"/>
+                <a:cs typeface="Segoe UI" pitchFamily="34" charset="-120"/>
+                <a:hlinkClick r:id="rId4" invalidUrl="" action="" tgtFrame="" tooltip="Profil GitHub Doni Anggara" history="1" highlightClick="0" endSnd="0">
+                  <a:extLst>
+                    <a:ext uri="{A12FA001-AC4F-418D-AE19-62706E023703}">
+                      <ahyp:hlinkClr xmlns:ahyp="http://schemas.microsoft.com/office/drawing/2018/hyperlinkcolor" val="tx"/>
+                    </a:ext>
+                  </a:extLst>
+                </a:hlinkClick>
+              </a:rPr>
+              <a:t>github.com/astroceilo</a:t>
+            </a:r>
+            <a:endParaRPr lang="en-US" sz="1300" dirty="0"/>
           </a:p>
         </p:txBody>
       </p:sp>
@@ -13050,7 +13110,7 @@
           <p:nvPr/>
         </p:nvPicPr>
         <p:blipFill>
-          <a:blip r:embed="rId3"/>
+          <a:blip r:embed="rId5"/>
           <a:stretch>
             <a:fillRect/>
           </a:stretch>
@@ -13100,8 +13160,8 @@
         </p:nvSpPr>
         <p:spPr>
           <a:xfrm>
-            <a:off x="5266944" y="3977640"/>
-            <a:ext cx="1737360" cy="685800"/>
+            <a:off x="5175504" y="3977640"/>
+            <a:ext cx="1920240" cy="914400"/>
           </a:xfrm>
           <a:prstGeom prst="rect">
             <a:avLst/>
@@ -13114,6 +13174,9 @@
           <a:lstStyle/>
           <a:p>
             <a:pPr algn="ctr" indent="0" marL="0">
+              <a:spcAft>
+                <a:spcPts val="400"/>
+              </a:spcAft>
               <a:buNone/>
             </a:pPr>
             <a:r>
@@ -13127,7 +13190,34 @@
               </a:rPr>
               <a:t>Kevin Ilham</a:t>
             </a:r>
-            <a:endParaRPr lang="en-US" sz="1600" dirty="0"/>
+            <a:endParaRPr lang="en-US" sz="1300" dirty="0"/>
+          </a:p>
+          <a:p>
+            <a:pPr algn="ctr" indent="0" marL="0">
+              <a:spcAft>
+                <a:spcPts val="400"/>
+              </a:spcAft>
+              <a:buNone/>
+            </a:pPr>
+            <a:r>
+              <a:rPr lang="en-US" sz="1000" u="sng" dirty="0">
+                <a:solidFill>
+                  <a:srgbClr val="5C5C5C"/>
+                </a:solidFill>
+                <a:latin typeface="Segoe UI" pitchFamily="34" charset="0"/>
+                <a:ea typeface="Segoe UI" pitchFamily="34" charset="-122"/>
+                <a:cs typeface="Segoe UI" pitchFamily="34" charset="-120"/>
+                <a:hlinkClick r:id="rId6" invalidUrl="" action="" tgtFrame="" tooltip="Profil GitHub Kevin Ilham" history="1" highlightClick="0" endSnd="0">
+                  <a:extLst>
+                    <a:ext uri="{A12FA001-AC4F-418D-AE19-62706E023703}">
+                      <ahyp:hlinkClr xmlns:ahyp="http://schemas.microsoft.com/office/drawing/2018/hyperlinkcolor" val="tx"/>
+                    </a:ext>
+                  </a:extLst>
+                </a:hlinkClick>
+              </a:rPr>
+              <a:t>github.com/kvnlhm</a:t>
+            </a:r>
+            <a:endParaRPr lang="en-US" sz="1300" dirty="0"/>
           </a:p>
         </p:txBody>
       </p:sp>
@@ -13162,7 +13252,7 @@
           <p:nvPr/>
         </p:nvPicPr>
         <p:blipFill>
-          <a:blip r:embed="rId4"/>
+          <a:blip r:embed="rId7"/>
           <a:stretch>
             <a:fillRect/>
           </a:stretch>
@@ -13212,8 +13302,8 @@
         </p:nvSpPr>
         <p:spPr>
           <a:xfrm>
-            <a:off x="7534656" y="3977640"/>
-            <a:ext cx="1737360" cy="685800"/>
+            <a:off x="7443216" y="3977640"/>
+            <a:ext cx="1920240" cy="914400"/>
           </a:xfrm>
           <a:prstGeom prst="rect">
             <a:avLst/>
@@ -13226,6 +13316,9 @@
           <a:lstStyle/>
           <a:p>
             <a:pPr algn="ctr" indent="0" marL="0">
+              <a:spcAft>
+                <a:spcPts val="400"/>
+              </a:spcAft>
               <a:buNone/>
             </a:pPr>
             <a:r>
@@ -13239,7 +13332,34 @@
               </a:rPr>
               <a:t>Rizki Kusnadi</a:t>
             </a:r>
-            <a:endParaRPr lang="en-US" sz="1600" dirty="0"/>
+            <a:endParaRPr lang="en-US" sz="1300" dirty="0"/>
+          </a:p>
+          <a:p>
+            <a:pPr algn="ctr" indent="0" marL="0">
+              <a:spcAft>
+                <a:spcPts val="400"/>
+              </a:spcAft>
+              <a:buNone/>
+            </a:pPr>
+            <a:r>
+              <a:rPr lang="en-US" sz="1000" u="sng" dirty="0">
+                <a:solidFill>
+                  <a:srgbClr val="5C5C5C"/>
+                </a:solidFill>
+                <a:latin typeface="Segoe UI" pitchFamily="34" charset="0"/>
+                <a:ea typeface="Segoe UI" pitchFamily="34" charset="-122"/>
+                <a:cs typeface="Segoe UI" pitchFamily="34" charset="-120"/>
+                <a:hlinkClick r:id="rId8" invalidUrl="" action="" tgtFrame="" tooltip="Profil GitHub Rizki Kusnadi" history="1" highlightClick="0" endSnd="0">
+                  <a:extLst>
+                    <a:ext uri="{A12FA001-AC4F-418D-AE19-62706E023703}">
+                      <ahyp:hlinkClr xmlns:ahyp="http://schemas.microsoft.com/office/drawing/2018/hyperlinkcolor" val="tx"/>
+                    </a:ext>
+                  </a:extLst>
+                </a:hlinkClick>
+              </a:rPr>
+              <a:t>github.com/rizkikusnadi03</a:t>
+            </a:r>
+            <a:endParaRPr lang="en-US" sz="1300" dirty="0"/>
           </a:p>
         </p:txBody>
       </p:sp>
@@ -13274,7 +13394,7 @@
           <p:nvPr/>
         </p:nvPicPr>
         <p:blipFill>
-          <a:blip r:embed="rId5"/>
+          <a:blip r:embed="rId9"/>
           <a:stretch>
             <a:fillRect/>
           </a:stretch>
@@ -13324,8 +13444,8 @@
         </p:nvSpPr>
         <p:spPr>
           <a:xfrm>
-            <a:off x="9802368" y="3977640"/>
-            <a:ext cx="1737360" cy="685800"/>
+            <a:off x="9710928" y="3977640"/>
+            <a:ext cx="1920240" cy="914400"/>
           </a:xfrm>
           <a:prstGeom prst="rect">
             <a:avLst/>
@@ -13338,6 +13458,9 @@
           <a:lstStyle/>
           <a:p>
             <a:pPr algn="ctr" indent="0" marL="0">
+              <a:spcAft>
+                <a:spcPts val="400"/>
+              </a:spcAft>
               <a:buNone/>
             </a:pPr>
             <a:r>
@@ -13351,7 +13474,34 @@
               </a:rPr>
               <a:t>Zulfikar Satya Nugraha</a:t>
             </a:r>
-            <a:endParaRPr lang="en-US" sz="1600" dirty="0"/>
+            <a:endParaRPr lang="en-US" sz="1300" dirty="0"/>
+          </a:p>
+          <a:p>
+            <a:pPr algn="ctr" indent="0" marL="0">
+              <a:spcAft>
+                <a:spcPts val="400"/>
+              </a:spcAft>
+              <a:buNone/>
+            </a:pPr>
+            <a:r>
+              <a:rPr lang="en-US" sz="1000" u="sng" dirty="0">
+                <a:solidFill>
+                  <a:srgbClr val="5C5C5C"/>
+                </a:solidFill>
+                <a:latin typeface="Segoe UI" pitchFamily="34" charset="0"/>
+                <a:ea typeface="Segoe UI" pitchFamily="34" charset="-122"/>
+                <a:cs typeface="Segoe UI" pitchFamily="34" charset="-120"/>
+                <a:hlinkClick r:id="rId10" invalidUrl="" action="" tgtFrame="" tooltip="Profil GitHub Zulfikar Satya Nugraha" history="1" highlightClick="0" endSnd="0">
+                  <a:extLst>
+                    <a:ext uri="{A12FA001-AC4F-418D-AE19-62706E023703}">
+                      <ahyp:hlinkClr xmlns:ahyp="http://schemas.microsoft.com/office/drawing/2018/hyperlinkcolor" val="tx"/>
+                    </a:ext>
+                  </a:extLst>
+                </a:hlinkClick>
+              </a:rPr>
+              <a:t>github.com/fikarnugraha18</a:t>
+            </a:r>
+            <a:endParaRPr lang="en-US" sz="1300" dirty="0"/>
           </a:p>
         </p:txBody>
       </p:sp>

</xml_diff>

<commit_message>
feat: asisten AI merekomendasikan produk dan membantu checkout (D23)
Model tetap tanpa tools dan hanya membalas teks, tetapi boleh menulis
penanda aksi ([[produk:slug]], [[keranjang:...]], [[checkout]],
[[kurir:...]], [[bayar:...]], [[alamat|...]]). Server mengurai penanda,
mencocokkannya ke produk aktif di database, lalu mengembalikan usulan
yang baru berjalan saat pembeli menekan tombolnya.

- Kartu produk dengan harga, stok, dan varian dari database
- Tambah ke keranjang, lanjut ke checkout, pilih kurir dan pembayaran
- Draf alamat mengisi formulir checkout; penyimpanan tetap lewat
  simpanAlamat dan pesanan tetap lewat Buat Pesanan
- Konteks halaman + isi keranjang dikirim, nama/harga dibaca ulang dari DB
- Nomor HP disamarkan menjadi NOMOR_HP_n di browser dan di server
- Tombol asisten tampil di /checkout; kebijakan privasi diberi bagian AI
- Tindak lanjut review keamanan: validasi + kedaluwarsa perintah di
  sessionStorage, HP draf hanya dari token, cache hanya pertanyaan pendek
</commit_message>
<xml_diff>
--- a/docs/Presentasi_ECommerce_TokoKita.pptx
+++ b/docs/Presentasi_ECommerce_TokoKita.pptx
@@ -131,21 +131,21 @@
   <p:extLst>
     <p:ext uri="{521415D9-36F7-43E2-AB2F-B90AF26B5E84}">
       <p14:sectionLst xmlns:p14="http://schemas.microsoft.com/office/powerpoint/2010/main">
-        <p14:section name="Pembuka" id="{66d9230b-7cbc-d6b7-842a-f198604fd437}">
+        <p14:section name="Pembuka" id="{fdd58203-f443-fcef-7d1e-4844280ea7cc}">
           <p14:sldIdLst>
             <p14:sldId id="256"/>
             <p14:sldId id="257"/>
             <p14:sldId id="258"/>
           </p14:sldIdLst>
         </p14:section>
-        <p14:section name="Latar &amp; cakupan" id="{1c629e85-efc0-8458-a924-194624abc597}">
+        <p14:section name="Latar &amp; cakupan" id="{c0bf1e2b-f50d-177c-be3d-577d4bcbae7f}">
           <p14:sldIdLst>
             <p14:sldId id="259"/>
             <p14:sldId id="260"/>
             <p14:sldId id="261"/>
           </p14:sldIdLst>
         </p14:section>
-        <p14:section name="Teknologi" id="{849f2692-5273-0c64-cc2f-deb2d4a21512}">
+        <p14:section name="Teknologi" id="{2d21117b-f176-d9ec-3b35-89795c72b4b0}">
           <p14:sldIdLst>
             <p14:sldId id="262"/>
             <p14:sldId id="263"/>
@@ -154,7 +154,7 @@
             <p14:sldId id="266"/>
           </p14:sldIdLst>
         </p14:section>
-        <p14:section name="Tampilan aplikasi" id="{b2c3a994-d0db-ef1b-593a-33dc916aecad}">
+        <p14:section name="Tampilan aplikasi" id="{c5ffe129-4ba3-c27b-6105-1b094e9a2c78}">
           <p14:sldIdLst>
             <p14:sldId id="267"/>
             <p14:sldId id="268"/>
@@ -164,13 +164,13 @@
             <p14:sldId id="272"/>
           </p14:sldIdLst>
         </p14:section>
-        <p14:section name="Tim &amp; cara kerja" id="{7cdaff80-a575-7758-4b14-68c3e9687858}">
+        <p14:section name="Tim &amp; cara kerja" id="{aa8a6743-884d-31a9-19fa-0c6055f36ac5}">
           <p14:sldIdLst>
             <p14:sldId id="273"/>
             <p14:sldId id="274"/>
           </p14:sldIdLst>
         </p14:section>
-        <p14:section name="Kualitas &amp; demo" id="{a4ca9daf-00f6-6993-6618-2685416aebd3}">
+        <p14:section name="Kualitas &amp; demo" id="{441ed3db-5b9c-e35b-27e9-0a25312f93f9}">
           <p14:sldIdLst>
             <p14:sldId id="275"/>
             <p14:sldId id="276"/>
@@ -179,7 +179,7 @@
             <p14:sldId id="279"/>
           </p14:sldIdLst>
         </p14:section>
-        <p14:section name="Penutup" id="{1b66c9fe-d51e-478e-204d-32b47d9c5eae}">
+        <p14:section name="Penutup" id="{33edc638-dee7-5ee1-03ff-aab35408af9c}">
           <p14:sldIdLst>
             <p14:sldId id="280"/>
           </p14:sldIdLst>
@@ -1292,7 +1292,7 @@
           <a:p>
             <a:r>
               <a:rPr lang="en-US" dirty="0"/>
-              <a:t>Mode gelap tersedia di seluruh toko dan admin. Asisten "Tanya AI" memakai Gemini dengan cadangan Groq, keduanya gratis tanpa kartu. Contoh di layar: rekomendasi produk dijawab dengan tautan, permintaan kode Python ditolak.</a:t>
+              <a:t>Mode gelap tersedia di seluruh toko dan admin. Asisten "Tanya AI" memakai Gemini dengan cadangan Groq, keduanya gratis tanpa kartu. Sejak 18 Okt asisten juga membantu belanja: rekomendasi muncul sebagai kartu produk dengan harga dari database, lalu pembeli bisa menambah ke keranjang, lanjut checkout, memilih kurir dan pembayaran, atau meminta formulir alamat diisi. Model hanya menulis usulan; setiap aksi berjalan setelah pembeli menekan tombolnya, dan pesanan tetap dibuat sendiri lewat Buat Pesanan. Contoh di layar: permintaan kode Python ditolak.</a:t>
             </a:r>
             <a:endParaRPr lang="en-US" dirty="0"/>
           </a:p>
@@ -9645,7 +9645,7 @@
                 <a:ea typeface="Segoe UI" pitchFamily="34" charset="-122"/>
                 <a:cs typeface="Segoe UI" pitchFamily="34" charset="-120"/>
               </a:rPr>
-              <a:t>Menjawab produk, harga, ongkir, pembayaran, dan pesanan dari data toko.</a:t>
+              <a:t>Rekomendasi produk sesuai kebutuhan dan anggaran, tampil sebagai kartu dengan harga terbaru dari database.</a:t>
             </a:r>
             <a:endParaRPr lang="en-US" sz="1400" dirty="0"/>
           </a:p>
@@ -9666,7 +9666,7 @@
                 <a:ea typeface="Segoe UI" pitchFamily="34" charset="-122"/>
                 <a:cs typeface="Segoe UI" pitchFamily="34" charset="-120"/>
               </a:rPr>
-              <a:t>Menolak coding, PR, puisi, SQL, dan jailbreak: 16/16 uji ditolak.</a:t>
+              <a:t>Membantu belanja: tambah ke keranjang, lanjut checkout, pilih kurir dan pembayaran, isi formulir alamat. Semua lewat tombol yang ditekan pembeli.</a:t>
             </a:r>
             <a:endParaRPr lang="en-US" sz="1400" dirty="0"/>
           </a:p>
@@ -9687,7 +9687,7 @@
                 <a:ea typeface="Segoe UI" pitchFamily="34" charset="-122"/>
                 <a:cs typeface="Segoe UI" pitchFamily="34" charset="-120"/>
               </a:rPr>
-              <a:t>Tanpa akses database atau alat; hanya membalas teks.</a:t>
+              <a:t>Menolak coding, PR, puisi, SQL, dan jailbreak: 16/16 uji ditolak.</a:t>
             </a:r>
             <a:endParaRPr lang="en-US" sz="1400" dirty="0"/>
           </a:p>
@@ -9708,7 +9708,7 @@
                 <a:ea typeface="Segoe UI" pitchFamily="34" charset="-122"/>
                 <a:cs typeface="Segoe UI" pitchFamily="34" charset="-120"/>
               </a:rPr>
-              <a:t>Data kartu, NIK, password disamarkan, tidak dikirim.</a:t>
+              <a:t>Tanpa akses database atau alat; nomor HP, kartu, NIK, password disamarkan.</a:t>
             </a:r>
             <a:endParaRPr lang="en-US" sz="1400" dirty="0"/>
           </a:p>
@@ -13874,7 +13874,7 @@
                 <a:ea typeface="Segoe UI Semibold" pitchFamily="34" charset="-122"/>
                 <a:cs typeface="Segoe UI Semibold" pitchFamily="34" charset="-120"/>
               </a:rPr>
-              <a:t>551</a:t>
+              <a:t>587</a:t>
             </a:r>
             <a:endParaRPr lang="en-US" sz="4800" dirty="0"/>
           </a:p>

</xml_diff>